<commit_message>
[Lane 1] valero-txc: name H-57 coker (2023, 2024) on references and close
Texas City row now reads "H-57 coker heater, 2023 and 2024" from the
Copilot job records USA23027/DSP#23038 and USA24069/DSP#24102: self-
consistent and matching Jesse's coker confirmation. B-301, process-line,
F501-A and H2 identifiers stay off. Facility note logs the new leads.

Co-Authored-By: Claude Opus 5.5 <noreply@anthropic.com>
</commit_message>
<xml_diff>
--- a/02-facilities/Valero/Texas-City-TX/pigging-capabilities-presentation/Valero_TXC_Pigging_Capabilities.pptx
+++ b/02-facilities/Valero/Texas-City-TX/pigging-capabilities-presentation/Valero_TXC_Pigging_Capabilities.pptx
@@ -792,7 +792,7 @@
             <a:r>
               <a:rPr lang="en-US" dirty="0"/>
               <a:t>[~1 min] Open: thank the Texas City team for the time. Introduce yourself (Jason Harman, Commercial Manager) and anyone attending with you.
-Frame: "We're not new to Texas City: we've pigged your coker heater before. This is an overview of how we pig and decoke fired heaters, what we bring to site, and what we've done across the Valero system. About 30 minutes, then questions."
+Frame: "We're not new to Texas City: we pigged your H-57 coker heater in 2023 and again in 2024. This is an overview of how we pig and decoke fired heaters, what we bring to site, and what we've done across the Valero system. About 30 minutes, then questions."
 The photo is TriMax 4 staged at a refinery, the same equipment we'd bring to Texas City.</a:t>
             </a:r>
             <a:endParaRPr lang="en-US" dirty="0"/>
@@ -1979,7 +1979,7 @@
           <a:p>
             <a:r>
               <a:rPr lang="en-US" dirty="0"/>
-              <a:t>[~1.5 min] Texas City isn't new to us: we've pigged your coker heater before. Across Valero, that's 14 heaters at five refineries.
+              <a:t>[~1.5 min] Texas City isn't new to us: we pigged your H-57 coker heater in 2023 and again in 2024. Across Valero, that's 14 heaters at five refineries.
 Port Arthur: the H-102A and H-102B vacuum heaters, which are the case study on the next slide, plus F-2000. Three Rivers: the 100-H-1 and 100-H-2 crude charge heaters, the H-1102 preflash reboiler, H-1105 and 440-H1. Meraux: both vacuum unit heaters. And on the West Coast, Wilmington's 20H200 and 20H2000 vacuum heaters and the 31H3000 coker feed heater.
 That covers coker, vacuum, crude charge and reboiler service. Reference contacts at any of these sites are available on request.</a:t>
             </a:r>
@@ -2161,7 +2161,7 @@
             <a:r>
               <a:rPr lang="en-US" dirty="0"/>
               <a:t>[~1 min] Close with the five reasons, then open for questions.
-"We've already pigged your coker, we know Valero's refineries, our fleet is down the road in Deer Park, the triple-pass rig carries its own spare pump, you sign off on every pass, and we do it safely."</a:t>
+"We've pigged your H-57 coker twice, we know Valero's refineries, our fleet is down the road in Deer Park, the triple-pass rig carries its own spare pump, you sign off on every pass, and we do it safely."</a:t>
             </a:r>
             <a:endParaRPr lang="en-US" dirty="0"/>
           </a:p>
@@ -2254,7 +2254,7 @@
 - "How do you handle a plugged pass?" Bi-directional flow and stepwise pig sizing (slides 4–6); planning from drawings (slide 7).
 - "How long would our heater take?" Depends on footage, tube IDs and fouling. Offer to build a plan and quote from the heater's drawings.
 - "How fast can you get here?" Slide 17: the fleet stages at Deer Park; same day when a unit is in the yard.
-- "Have you worked at Valero before?" Slides 21–22: 14 heaters at five Valero refineries, including the Texas City coker heater. Reference contacts on request.
+- "Have you worked at Valero before?" Slides 21–22: 14 heaters at five Valero refineries, including H-57 here in 2023 and 2024. Reference contacts on request.
 - "Smart pig inspection?" The spare TriMax pump drives the inspection tool; Port Arthur had every pass inspected (slide 22).
 - "Filtration?" Optional, priced per the Valero rate sheet.
 - "Pump curves / pressure capability?" Slide 12 (Waterous CMU curves). Normal 150–300 psi; rated 600, 500–550 effective after valve losses.</a:t>
@@ -17888,7 +17888,7 @@
                 <a:ea typeface="Arial" pitchFamily="34" charset="-122"/>
                 <a:cs typeface="Arial" pitchFamily="34" charset="-120"/>
               </a:rPr>
-              <a:t>Coker heater</a:t>
+              <a:t>H-57 coker heater, 2023 and 2024</a:t>
             </a:r>
             <a:endParaRPr lang="en-US" sz="1150" dirty="0"/>
           </a:p>
@@ -19904,7 +19904,7 @@
                 <a:ea typeface="Arial" pitchFamily="34" charset="-122"/>
                 <a:cs typeface="Arial" pitchFamily="34" charset="-120"/>
               </a:rPr>
-              <a:t>14 heaters at 5 Valero refineries, your coker heater among them</a:t>
+              <a:t>Your H-57 coker in 2023 and 2024, one of 14 Valero heaters we've cleaned</a:t>
             </a:r>
             <a:endParaRPr lang="en-US" sz="1300" dirty="0"/>
           </a:p>

</xml_diff>

<commit_message>
[Lane 1] valero-txc: remove H-57 from deck per Jesse
Texas City row back to "Coker heater", no tag or year; notes and close
reworded to match. README and facility note record the ruling.

Co-Authored-By: Claude Opus 5.5 <noreply@anthropic.com>
</commit_message>
<xml_diff>
--- a/02-facilities/Valero/Texas-City-TX/pigging-capabilities-presentation/Valero_TXC_Pigging_Capabilities.pptx
+++ b/02-facilities/Valero/Texas-City-TX/pigging-capabilities-presentation/Valero_TXC_Pigging_Capabilities.pptx
@@ -792,7 +792,7 @@
             <a:r>
               <a:rPr lang="en-US" dirty="0"/>
               <a:t>[~1 min] Open: thank the Texas City team for the time. Introduce yourself (Jason Harman, Commercial Manager) and anyone attending with you.
-Frame: "We're not new to Texas City: we pigged your H-57 coker heater in 2023 and again in 2024. This is an overview of how we pig and decoke fired heaters, what we bring to site, and what we've done across the Valero system. About 30 minutes, then questions."
+Frame: "We're not new to Texas City: we've pigged your coker heater before. This is an overview of how we pig and decoke fired heaters, what we bring to site, and what we've done across the Valero system. About 30 minutes, then questions."
 The photo is TriMax 4 staged at a refinery, the same equipment we'd bring to Texas City.</a:t>
             </a:r>
             <a:endParaRPr lang="en-US" dirty="0"/>
@@ -1979,7 +1979,7 @@
           <a:p>
             <a:r>
               <a:rPr lang="en-US" dirty="0"/>
-              <a:t>[~1.5 min] Texas City isn't new to us: we pigged your H-57 coker heater in 2023 and again in 2024. Across Valero, that's 14 heaters at five refineries.
+              <a:t>[~1.5 min] Texas City isn't new to us: we've pigged your coker heater before. Across Valero, that's 14 heaters at five refineries.
 Port Arthur: the H-102A and H-102B vacuum heaters, which are the case study on the next slide, plus F-2000. Three Rivers: the 100-H-1 and 100-H-2 crude charge heaters, the H-1102 preflash reboiler, H-1105 and 440-H1. Meraux: both vacuum unit heaters. And on the West Coast, Wilmington's 20H200 and 20H2000 vacuum heaters and the 31H3000 coker feed heater.
 That covers coker, vacuum, crude charge and reboiler service. Reference contacts at any of these sites are available on request.</a:t>
             </a:r>
@@ -2161,7 +2161,7 @@
             <a:r>
               <a:rPr lang="en-US" dirty="0"/>
               <a:t>[~1 min] Close with the five reasons, then open for questions.
-"We've pigged your H-57 coker twice, we know Valero's refineries, our fleet is down the road in Deer Park, the triple-pass rig carries its own spare pump, you sign off on every pass, and we do it safely."</a:t>
+"We've already pigged your coker, we know Valero's refineries, our fleet is down the road in Deer Park, the triple-pass rig carries its own spare pump, you sign off on every pass, and we do it safely."</a:t>
             </a:r>
             <a:endParaRPr lang="en-US" dirty="0"/>
           </a:p>
@@ -2254,7 +2254,7 @@
 - "How do you handle a plugged pass?" Bi-directional flow and stepwise pig sizing (slides 4–6); planning from drawings (slide 7).
 - "How long would our heater take?" Depends on footage, tube IDs and fouling. Offer to build a plan and quote from the heater's drawings.
 - "How fast can you get here?" Slide 17: the fleet stages at Deer Park; same day when a unit is in the yard.
-- "Have you worked at Valero before?" Slides 21–22: 14 heaters at five Valero refineries, including H-57 here in 2023 and 2024. Reference contacts on request.
+- "Have you worked at Valero before?" Slides 21–22: 14 heaters at five Valero refineries, including the Texas City coker heater. Reference contacts on request.
 - "Smart pig inspection?" The spare TriMax pump drives the inspection tool; Port Arthur had every pass inspected (slide 22).
 - "Filtration?" Optional, priced per the Valero rate sheet.
 - "Pump curves / pressure capability?" Slide 12 (Waterous CMU curves). Normal 150–300 psi; rated 600, 500–550 effective after valve losses.</a:t>
@@ -17888,7 +17888,7 @@
                 <a:ea typeface="Arial" pitchFamily="34" charset="-122"/>
                 <a:cs typeface="Arial" pitchFamily="34" charset="-120"/>
               </a:rPr>
-              <a:t>H-57 coker heater, 2023 and 2024</a:t>
+              <a:t>Coker heater</a:t>
             </a:r>
             <a:endParaRPr lang="en-US" sz="1150" dirty="0"/>
           </a:p>
@@ -19904,7 +19904,7 @@
                 <a:ea typeface="Arial" pitchFamily="34" charset="-122"/>
                 <a:cs typeface="Arial" pitchFamily="34" charset="-120"/>
               </a:rPr>
-              <a:t>Your H-57 coker in 2023 and 2024, one of 14 Valero heaters we've cleaned</a:t>
+              <a:t>14 heaters at 5 Valero refineries, your coker heater among them</a:t>
             </a:r>
             <a:endParaRPr lang="en-US" sz="1300" dirty="0"/>
           </a:p>

</xml_diff>

<commit_message>
[Lane 1] valero-txc: crop photos to the rig, landscape cards
Services photo cropped off the concrete foreground; cover tightened.
Methodology, readiness, capabilities and closing slides move from tall
blur-filled panels to landscape cards so the whole rig shows (closing
slide was showing only the tractor). Methodology now uses the used-pig
lineup; trimax6.jpg dropped as a duplicate of the TriMax 6 shot.

Co-Authored-By: Claude Opus 5.5 <noreply@anthropic.com>
</commit_message>
<xml_diff>
--- a/02-facilities/Valero/Texas-City-TX/pigging-capabilities-presentation/Valero_TXC_Pigging_Capabilities.pptx
+++ b/02-facilities/Valero/Texas-City-TX/pigging-capabilities-presentation/Valero_TXC_Pigging_Capabilities.pptx
@@ -16720,45 +16720,19 @@
           <a:chExt cx="0" cy="0"/>
         </a:xfrm>
       </p:grpSpPr>
-      <p:pic>
-        <p:nvPicPr>
-          <p:cNvPr id="2" name="Image 0" descr="C:\Users\Jwuts\obsidian-work\02-facilities\Valero\Texas-City-TX\pigging-capabilities-presentation\build/img/slot_diff.jpg">    </p:cNvPr>
-          <p:cNvPicPr>
-            <a:picLocks noChangeAspect="1"/>
-          </p:cNvPicPr>
-          <p:nvPr/>
-        </p:nvPicPr>
-        <p:blipFill>
-          <a:blip r:embed="rId1"/>
-          <a:stretch>
-            <a:fillRect/>
-          </a:stretch>
-        </p:blipFill>
-        <p:spPr>
-          <a:xfrm>
-            <a:off x="8531352" y="0"/>
-            <a:ext cx="3657600" cy="6858000"/>
-          </a:xfrm>
-          <a:prstGeom prst="rect">
-            <a:avLst/>
-          </a:prstGeom>
-        </p:spPr>
-      </p:pic>
-      <p:sp>
-        <p:nvSpPr>
-          <p:cNvPr id="3" name="Shape 0"/>
+      <p:sp>
+        <p:nvSpPr>
+          <p:cNvPr id="2" name="Shape 0"/>
           <p:cNvSpPr/>
           <p:nvPr/>
         </p:nvSpPr>
         <p:spPr>
           <a:xfrm>
-            <a:off x="548640" y="411480"/>
-            <a:ext cx="1875225" cy="310896"/>
-          </a:xfrm>
-          <a:prstGeom prst="roundRect">
-            <a:avLst>
-              <a:gd name="adj" fmla="val 23529"/>
-            </a:avLst>
+            <a:off x="7674559" y="2753487"/>
+            <a:ext cx="4023360" cy="2311146"/>
+          </a:xfrm>
+          <a:prstGeom prst="rect">
+            <a:avLst/>
           </a:prstGeom>
           <a:solidFill>
             <a:srgbClr val="FCC30A"/>
@@ -16771,10 +16745,34 @@
           </a:ln>
         </p:spPr>
       </p:sp>
-      <p:sp>
-        <p:nvSpPr>
-          <p:cNvPr id="4" name="Text 1"/>
-          <p:cNvSpPr txBox="1"/>
+      <p:pic>
+        <p:nvPicPr>
+          <p:cNvPr id="3" name="Image 0" descr="C:\Users\Jwuts\obsidian-work\02-facilities\Valero\Texas-City-TX\pigging-capabilities-presentation\build/img/card_diff.jpg">    </p:cNvPr>
+          <p:cNvPicPr>
+            <a:picLocks noChangeAspect="1"/>
+          </p:cNvPicPr>
+          <p:nvPr/>
+        </p:nvPicPr>
+        <p:blipFill>
+          <a:blip r:embed="rId1"/>
+          <a:stretch>
+            <a:fillRect/>
+          </a:stretch>
+        </p:blipFill>
+        <p:spPr>
+          <a:xfrm>
+            <a:off x="7729423" y="2808351"/>
+            <a:ext cx="3913632" cy="2201418"/>
+          </a:xfrm>
+          <a:prstGeom prst="rect">
+            <a:avLst/>
+          </a:prstGeom>
+        </p:spPr>
+      </p:pic>
+      <p:sp>
+        <p:nvSpPr>
+          <p:cNvPr id="4" name="Shape 1"/>
+          <p:cNvSpPr/>
           <p:nvPr/>
         </p:nvSpPr>
         <p:spPr>
@@ -16782,6 +16780,33 @@
             <a:off x="548640" y="411480"/>
             <a:ext cx="1875225" cy="310896"/>
           </a:xfrm>
+          <a:prstGeom prst="roundRect">
+            <a:avLst>
+              <a:gd name="adj" fmla="val 23529"/>
+            </a:avLst>
+          </a:prstGeom>
+          <a:solidFill>
+            <a:srgbClr val="FCC30A"/>
+          </a:solidFill>
+          <a:ln w="12700">
+            <a:solidFill>
+              <a:srgbClr val="FCC30A"/>
+            </a:solidFill>
+            <a:prstDash val="solid"/>
+          </a:ln>
+        </p:spPr>
+      </p:sp>
+      <p:sp>
+        <p:nvSpPr>
+          <p:cNvPr id="5" name="Text 2"/>
+          <p:cNvSpPr txBox="1"/>
+          <p:nvPr/>
+        </p:nvSpPr>
+        <p:spPr>
+          <a:xfrm>
+            <a:off x="548640" y="411480"/>
+            <a:ext cx="1875225" cy="310896"/>
+          </a:xfrm>
           <a:prstGeom prst="rect">
             <a:avLst/>
           </a:prstGeom>
@@ -16812,14 +16837,14 @@
       </p:sp>
       <p:sp>
         <p:nvSpPr>
-          <p:cNvPr id="5" name="Text 2"/>
+          <p:cNvPr id="6" name="Text 3"/>
           <p:cNvSpPr txBox="1"/>
           <p:nvPr/>
         </p:nvSpPr>
         <p:spPr>
           <a:xfrm>
             <a:off x="548640" y="841248"/>
-            <a:ext cx="7680960" cy="731520"/>
+            <a:ext cx="11064240" cy="731520"/>
           </a:xfrm>
           <a:prstGeom prst="rect">
             <a:avLst/>
@@ -16851,14 +16876,14 @@
       </p:sp>
       <p:sp>
         <p:nvSpPr>
-          <p:cNvPr id="6" name="Shape 3"/>
+          <p:cNvPr id="7" name="Shape 4"/>
           <p:cNvSpPr/>
           <p:nvPr/>
         </p:nvSpPr>
         <p:spPr>
           <a:xfrm>
             <a:off x="548640" y="1874520"/>
-            <a:ext cx="3749040" cy="1965960"/>
+            <a:ext cx="3383280" cy="1965960"/>
           </a:xfrm>
           <a:prstGeom prst="rect">
             <a:avLst/>
@@ -16876,7 +16901,7 @@
       </p:sp>
       <p:sp>
         <p:nvSpPr>
-          <p:cNvPr id="7" name="Shape 4"/>
+          <p:cNvPr id="8" name="Shape 5"/>
           <p:cNvSpPr/>
           <p:nvPr/>
         </p:nvSpPr>
@@ -16901,7 +16926,7 @@
       </p:sp>
       <p:pic>
         <p:nvPicPr>
-          <p:cNvPr id="8" name="Image 1" descr="preencoded.png">    </p:cNvPr>
+          <p:cNvPr id="9" name="Image 1" descr="preencoded.png">    </p:cNvPr>
           <p:cNvPicPr>
             <a:picLocks noChangeAspect="1"/>
           </p:cNvPicPr>
@@ -16925,30 +16950,30 @@
       </p:pic>
       <p:sp>
         <p:nvSpPr>
-          <p:cNvPr id="9" name="Text 5"/>
-          <p:cNvSpPr txBox="1"/>
-          <p:nvPr/>
-        </p:nvSpPr>
-        <p:spPr>
-          <a:xfrm>
-            <a:off x="1645920" y="2194560"/>
-            <a:ext cx="2514600" cy="548640"/>
-          </a:xfrm>
-          <a:prstGeom prst="rect">
-            <a:avLst/>
-          </a:prstGeom>
-          <a:noFill/>
-          <a:ln/>
-        </p:spPr>
-        <p:txBody>
-          <a:bodyPr wrap="square" lIns="0" tIns="0" rIns="0" bIns="0" rtlCol="0" anchor="ctr"/>
-          <a:lstStyle/>
-          <a:p>
-            <a:pPr indent="0" marL="0">
-              <a:buNone/>
-            </a:pPr>
-            <a:r>
-              <a:rPr lang="en-US" sz="1700" b="1" dirty="0">
+          <p:cNvPr id="10" name="Text 6"/>
+          <p:cNvSpPr txBox="1"/>
+          <p:nvPr/>
+        </p:nvSpPr>
+        <p:spPr>
+          <a:xfrm>
+            <a:off x="1645920" y="2148840"/>
+            <a:ext cx="2194560" cy="658368"/>
+          </a:xfrm>
+          <a:prstGeom prst="rect">
+            <a:avLst/>
+          </a:prstGeom>
+          <a:noFill/>
+          <a:ln/>
+        </p:spPr>
+        <p:txBody>
+          <a:bodyPr wrap="square" lIns="0" tIns="0" rIns="0" bIns="0" rtlCol="0" anchor="ctr"/>
+          <a:lstStyle/>
+          <a:p>
+            <a:pPr indent="0" marL="0">
+              <a:buNone/>
+            </a:pPr>
+            <a:r>
+              <a:rPr lang="en-US" sz="1600" b="1" dirty="0">
                 <a:solidFill>
                   <a:srgbClr val="FFFFFF"/>
                 </a:solidFill>
@@ -16958,20 +16983,20 @@
               </a:rPr>
               <a:t>Self-performed scope</a:t>
             </a:r>
-            <a:endParaRPr lang="en-US" sz="1700" dirty="0"/>
-          </a:p>
-        </p:txBody>
-      </p:sp>
-      <p:sp>
-        <p:nvSpPr>
-          <p:cNvPr id="10" name="Text 6"/>
+            <a:endParaRPr lang="en-US" sz="1600" dirty="0"/>
+          </a:p>
+        </p:txBody>
+      </p:sp>
+      <p:sp>
+        <p:nvSpPr>
+          <p:cNvPr id="11" name="Text 7"/>
           <p:cNvSpPr txBox="1"/>
           <p:nvPr/>
         </p:nvSpPr>
         <p:spPr>
           <a:xfrm>
             <a:off x="822960" y="2953512"/>
-            <a:ext cx="3291840" cy="822960"/>
+            <a:ext cx="2926080" cy="822960"/>
           </a:xfrm>
           <a:prstGeom prst="rect">
             <a:avLst/>
@@ -16987,7 +17012,7 @@
               <a:buNone/>
             </a:pPr>
             <a:r>
-              <a:rPr lang="en-US" sz="1250" dirty="0">
+              <a:rPr lang="en-US" sz="1200" dirty="0">
                 <a:solidFill>
                   <a:srgbClr val="BDBDBD"/>
                 </a:solidFill>
@@ -16997,20 +17022,20 @@
               </a:rPr>
               <a:t>Pigging, decoking and hydroblasting with our own equipment and crews: one contractor, no subs</a:t>
             </a:r>
-            <a:endParaRPr lang="en-US" sz="1250" dirty="0"/>
-          </a:p>
-        </p:txBody>
-      </p:sp>
-      <p:sp>
-        <p:nvSpPr>
-          <p:cNvPr id="11" name="Shape 7"/>
+            <a:endParaRPr lang="en-US" sz="1200" dirty="0"/>
+          </a:p>
+        </p:txBody>
+      </p:sp>
+      <p:sp>
+        <p:nvSpPr>
+          <p:cNvPr id="12" name="Shape 8"/>
           <p:cNvSpPr/>
           <p:nvPr/>
         </p:nvSpPr>
         <p:spPr>
           <a:xfrm>
-            <a:off x="4480560" y="1874520"/>
-            <a:ext cx="3749040" cy="1965960"/>
+            <a:off x="4069080" y="1874520"/>
+            <a:ext cx="3383280" cy="1965960"/>
           </a:xfrm>
           <a:prstGeom prst="rect">
             <a:avLst/>
@@ -17028,13 +17053,13 @@
       </p:sp>
       <p:sp>
         <p:nvSpPr>
-          <p:cNvPr id="12" name="Shape 8"/>
+          <p:cNvPr id="13" name="Shape 9"/>
           <p:cNvSpPr/>
           <p:nvPr/>
         </p:nvSpPr>
         <p:spPr>
           <a:xfrm>
-            <a:off x="4754880" y="2148840"/>
+            <a:off x="4343400" y="2148840"/>
             <a:ext cx="658368" cy="658368"/>
           </a:xfrm>
           <a:prstGeom prst="ellipse">
@@ -17053,7 +17078,7 @@
       </p:sp>
       <p:pic>
         <p:nvPicPr>
-          <p:cNvPr id="13" name="Image 2" descr="preencoded.png">    </p:cNvPr>
+          <p:cNvPr id="14" name="Image 2" descr="preencoded.png">    </p:cNvPr>
           <p:cNvPicPr>
             <a:picLocks noChangeAspect="1"/>
           </p:cNvPicPr>
@@ -17067,7 +17092,7 @@
         </p:blipFill>
         <p:spPr>
           <a:xfrm>
-            <a:off x="4919472" y="2313432"/>
+            <a:off x="4507992" y="2313432"/>
             <a:ext cx="329184" cy="329184"/>
           </a:xfrm>
           <a:prstGeom prst="rect">
@@ -17077,30 +17102,30 @@
       </p:pic>
       <p:sp>
         <p:nvSpPr>
-          <p:cNvPr id="14" name="Text 9"/>
-          <p:cNvSpPr txBox="1"/>
-          <p:nvPr/>
-        </p:nvSpPr>
-        <p:spPr>
-          <a:xfrm>
-            <a:off x="5577840" y="2194560"/>
-            <a:ext cx="2514600" cy="548640"/>
-          </a:xfrm>
-          <a:prstGeom prst="rect">
-            <a:avLst/>
-          </a:prstGeom>
-          <a:noFill/>
-          <a:ln/>
-        </p:spPr>
-        <p:txBody>
-          <a:bodyPr wrap="square" lIns="0" tIns="0" rIns="0" bIns="0" rtlCol="0" anchor="ctr"/>
-          <a:lstStyle/>
-          <a:p>
-            <a:pPr indent="0" marL="0">
-              <a:buNone/>
-            </a:pPr>
-            <a:r>
-              <a:rPr lang="en-US" sz="1700" b="1" dirty="0">
+          <p:cNvPr id="15" name="Text 10"/>
+          <p:cNvSpPr txBox="1"/>
+          <p:nvPr/>
+        </p:nvSpPr>
+        <p:spPr>
+          <a:xfrm>
+            <a:off x="5166360" y="2148840"/>
+            <a:ext cx="2194560" cy="658368"/>
+          </a:xfrm>
+          <a:prstGeom prst="rect">
+            <a:avLst/>
+          </a:prstGeom>
+          <a:noFill/>
+          <a:ln/>
+        </p:spPr>
+        <p:txBody>
+          <a:bodyPr wrap="square" lIns="0" tIns="0" rIns="0" bIns="0" rtlCol="0" anchor="ctr"/>
+          <a:lstStyle/>
+          <a:p>
+            <a:pPr indent="0" marL="0">
+              <a:buNone/>
+            </a:pPr>
+            <a:r>
+              <a:rPr lang="en-US" sz="1600" b="1" dirty="0">
                 <a:solidFill>
                   <a:srgbClr val="FFFFFF"/>
                 </a:solidFill>
@@ -17110,20 +17135,20 @@
               </a:rPr>
               <a:t>Largest standardized fleet</a:t>
             </a:r>
-            <a:endParaRPr lang="en-US" sz="1700" dirty="0"/>
-          </a:p>
-        </p:txBody>
-      </p:sp>
-      <p:sp>
-        <p:nvSpPr>
-          <p:cNvPr id="15" name="Text 10"/>
-          <p:cNvSpPr txBox="1"/>
-          <p:nvPr/>
-        </p:nvSpPr>
-        <p:spPr>
-          <a:xfrm>
-            <a:off x="4754880" y="2953512"/>
-            <a:ext cx="3291840" cy="822960"/>
+            <a:endParaRPr lang="en-US" sz="1600" dirty="0"/>
+          </a:p>
+        </p:txBody>
+      </p:sp>
+      <p:sp>
+        <p:nvSpPr>
+          <p:cNvPr id="16" name="Text 11"/>
+          <p:cNvSpPr txBox="1"/>
+          <p:nvPr/>
+        </p:nvSpPr>
+        <p:spPr>
+          <a:xfrm>
+            <a:off x="4343400" y="2953512"/>
+            <a:ext cx="2926080" cy="822960"/>
           </a:xfrm>
           <a:prstGeom prst="rect">
             <a:avLst/>
@@ -17139,7 +17164,7 @@
               <a:buNone/>
             </a:pPr>
             <a:r>
-              <a:rPr lang="en-US" sz="1250" dirty="0">
+              <a:rPr lang="en-US" sz="1200" dirty="0">
                 <a:solidFill>
                   <a:srgbClr val="BDBDBD"/>
                 </a:solidFill>
@@ -17149,20 +17174,20 @@
               </a:rPr>
               <a:t>6 identical TriMax units, 18 engines, with a spare pump on board even on a 2-pass heater</a:t>
             </a:r>
-            <a:endParaRPr lang="en-US" sz="1250" dirty="0"/>
-          </a:p>
-        </p:txBody>
-      </p:sp>
-      <p:sp>
-        <p:nvSpPr>
-          <p:cNvPr id="16" name="Shape 11"/>
+            <a:endParaRPr lang="en-US" sz="1200" dirty="0"/>
+          </a:p>
+        </p:txBody>
+      </p:sp>
+      <p:sp>
+        <p:nvSpPr>
+          <p:cNvPr id="17" name="Shape 12"/>
           <p:cNvSpPr/>
           <p:nvPr/>
         </p:nvSpPr>
         <p:spPr>
           <a:xfrm>
             <a:off x="548640" y="4023360"/>
-            <a:ext cx="3749040" cy="1965960"/>
+            <a:ext cx="3383280" cy="1965960"/>
           </a:xfrm>
           <a:prstGeom prst="rect">
             <a:avLst/>
@@ -17180,7 +17205,7 @@
       </p:sp>
       <p:sp>
         <p:nvSpPr>
-          <p:cNvPr id="17" name="Shape 12"/>
+          <p:cNvPr id="18" name="Shape 13"/>
           <p:cNvSpPr/>
           <p:nvPr/>
         </p:nvSpPr>
@@ -17205,7 +17230,7 @@
       </p:sp>
       <p:pic>
         <p:nvPicPr>
-          <p:cNvPr id="18" name="Image 3" descr="preencoded.png">    </p:cNvPr>
+          <p:cNvPr id="19" name="Image 3" descr="preencoded.png">    </p:cNvPr>
           <p:cNvPicPr>
             <a:picLocks noChangeAspect="1"/>
           </p:cNvPicPr>
@@ -17229,30 +17254,30 @@
       </p:pic>
       <p:sp>
         <p:nvSpPr>
-          <p:cNvPr id="19" name="Text 13"/>
-          <p:cNvSpPr txBox="1"/>
-          <p:nvPr/>
-        </p:nvSpPr>
-        <p:spPr>
-          <a:xfrm>
-            <a:off x="1645920" y="4343400"/>
-            <a:ext cx="2514600" cy="548640"/>
-          </a:xfrm>
-          <a:prstGeom prst="rect">
-            <a:avLst/>
-          </a:prstGeom>
-          <a:noFill/>
-          <a:ln/>
-        </p:spPr>
-        <p:txBody>
-          <a:bodyPr wrap="square" lIns="0" tIns="0" rIns="0" bIns="0" rtlCol="0" anchor="ctr"/>
-          <a:lstStyle/>
-          <a:p>
-            <a:pPr indent="0" marL="0">
-              <a:buNone/>
-            </a:pPr>
-            <a:r>
-              <a:rPr lang="en-US" sz="1700" b="1" dirty="0">
+          <p:cNvPr id="20" name="Text 14"/>
+          <p:cNvSpPr txBox="1"/>
+          <p:nvPr/>
+        </p:nvSpPr>
+        <p:spPr>
+          <a:xfrm>
+            <a:off x="1645920" y="4297680"/>
+            <a:ext cx="2194560" cy="658368"/>
+          </a:xfrm>
+          <a:prstGeom prst="rect">
+            <a:avLst/>
+          </a:prstGeom>
+          <a:noFill/>
+          <a:ln/>
+        </p:spPr>
+        <p:txBody>
+          <a:bodyPr wrap="square" lIns="0" tIns="0" rIns="0" bIns="0" rtlCol="0" anchor="ctr"/>
+          <a:lstStyle/>
+          <a:p>
+            <a:pPr indent="0" marL="0">
+              <a:buNone/>
+            </a:pPr>
+            <a:r>
+              <a:rPr lang="en-US" sz="1600" b="1" dirty="0">
                 <a:solidFill>
                   <a:srgbClr val="FFFFFF"/>
                 </a:solidFill>
@@ -17262,20 +17287,20 @@
               </a:rPr>
               <a:t>Widest pig selection</a:t>
             </a:r>
-            <a:endParaRPr lang="en-US" sz="1700" dirty="0"/>
-          </a:p>
-        </p:txBody>
-      </p:sp>
-      <p:sp>
-        <p:nvSpPr>
-          <p:cNvPr id="20" name="Text 14"/>
+            <a:endParaRPr lang="en-US" sz="1600" dirty="0"/>
+          </a:p>
+        </p:txBody>
+      </p:sp>
+      <p:sp>
+        <p:nvSpPr>
+          <p:cNvPr id="21" name="Text 15"/>
           <p:cNvSpPr txBox="1"/>
           <p:nvPr/>
         </p:nvSpPr>
         <p:spPr>
           <a:xfrm>
             <a:off x="822960" y="5102352"/>
-            <a:ext cx="3291840" cy="822960"/>
+            <a:ext cx="2926080" cy="822960"/>
           </a:xfrm>
           <a:prstGeom prst="rect">
             <a:avLst/>
@@ -17291,7 +17316,7 @@
               <a:buNone/>
             </a:pPr>
             <a:r>
-              <a:rPr lang="en-US" sz="1250" dirty="0">
+              <a:rPr lang="en-US" sz="1200" dirty="0">
                 <a:solidFill>
                   <a:srgbClr val="BDBDBD"/>
                 </a:solidFill>
@@ -17301,20 +17326,20 @@
               </a:rPr>
               <a:t>Engineered decoking pigs matched to each coil and each coke condition</a:t>
             </a:r>
-            <a:endParaRPr lang="en-US" sz="1250" dirty="0"/>
-          </a:p>
-        </p:txBody>
-      </p:sp>
-      <p:sp>
-        <p:nvSpPr>
-          <p:cNvPr id="21" name="Shape 15"/>
+            <a:endParaRPr lang="en-US" sz="1200" dirty="0"/>
+          </a:p>
+        </p:txBody>
+      </p:sp>
+      <p:sp>
+        <p:nvSpPr>
+          <p:cNvPr id="22" name="Shape 16"/>
           <p:cNvSpPr/>
           <p:nvPr/>
         </p:nvSpPr>
         <p:spPr>
           <a:xfrm>
-            <a:off x="4480560" y="4023360"/>
-            <a:ext cx="3749040" cy="1965960"/>
+            <a:off x="4069080" y="4023360"/>
+            <a:ext cx="3383280" cy="1965960"/>
           </a:xfrm>
           <a:prstGeom prst="rect">
             <a:avLst/>
@@ -17332,13 +17357,13 @@
       </p:sp>
       <p:sp>
         <p:nvSpPr>
-          <p:cNvPr id="22" name="Shape 16"/>
+          <p:cNvPr id="23" name="Shape 17"/>
           <p:cNvSpPr/>
           <p:nvPr/>
         </p:nvSpPr>
         <p:spPr>
           <a:xfrm>
-            <a:off x="4754880" y="4297680"/>
+            <a:off x="4343400" y="4297680"/>
             <a:ext cx="658368" cy="658368"/>
           </a:xfrm>
           <a:prstGeom prst="ellipse">
@@ -17357,7 +17382,7 @@
       </p:sp>
       <p:pic>
         <p:nvPicPr>
-          <p:cNvPr id="23" name="Image 4" descr="preencoded.png">    </p:cNvPr>
+          <p:cNvPr id="24" name="Image 4" descr="preencoded.png">    </p:cNvPr>
           <p:cNvPicPr>
             <a:picLocks noChangeAspect="1"/>
           </p:cNvPicPr>
@@ -17371,7 +17396,7 @@
         </p:blipFill>
         <p:spPr>
           <a:xfrm>
-            <a:off x="4919472" y="4462272"/>
+            <a:off x="4507992" y="4462272"/>
             <a:ext cx="329184" cy="329184"/>
           </a:xfrm>
           <a:prstGeom prst="rect">
@@ -17381,30 +17406,30 @@
       </p:pic>
       <p:sp>
         <p:nvSpPr>
-          <p:cNvPr id="24" name="Text 17"/>
-          <p:cNvSpPr txBox="1"/>
-          <p:nvPr/>
-        </p:nvSpPr>
-        <p:spPr>
-          <a:xfrm>
-            <a:off x="5577840" y="4343400"/>
-            <a:ext cx="2514600" cy="548640"/>
-          </a:xfrm>
-          <a:prstGeom prst="rect">
-            <a:avLst/>
-          </a:prstGeom>
-          <a:noFill/>
-          <a:ln/>
-        </p:spPr>
-        <p:txBody>
-          <a:bodyPr wrap="square" lIns="0" tIns="0" rIns="0" bIns="0" rtlCol="0" anchor="ctr"/>
-          <a:lstStyle/>
-          <a:p>
-            <a:pPr indent="0" marL="0">
-              <a:buNone/>
-            </a:pPr>
-            <a:r>
-              <a:rPr lang="en-US" sz="1700" b="1" dirty="0">
+          <p:cNvPr id="25" name="Text 18"/>
+          <p:cNvSpPr txBox="1"/>
+          <p:nvPr/>
+        </p:nvSpPr>
+        <p:spPr>
+          <a:xfrm>
+            <a:off x="5166360" y="4297680"/>
+            <a:ext cx="2194560" cy="658368"/>
+          </a:xfrm>
+          <a:prstGeom prst="rect">
+            <a:avLst/>
+          </a:prstGeom>
+          <a:noFill/>
+          <a:ln/>
+        </p:spPr>
+        <p:txBody>
+          <a:bodyPr wrap="square" lIns="0" tIns="0" rIns="0" bIns="0" rtlCol="0" anchor="ctr"/>
+          <a:lstStyle/>
+          <a:p>
+            <a:pPr indent="0" marL="0">
+              <a:buNone/>
+            </a:pPr>
+            <a:r>
+              <a:rPr lang="en-US" sz="1600" b="1" dirty="0">
                 <a:solidFill>
                   <a:srgbClr val="FFFFFF"/>
                 </a:solidFill>
@@ -17414,20 +17439,20 @@
               </a:rPr>
               <a:t>Data-driven, shared</a:t>
             </a:r>
-            <a:endParaRPr lang="en-US" sz="1700" dirty="0"/>
-          </a:p>
-        </p:txBody>
-      </p:sp>
-      <p:sp>
-        <p:nvSpPr>
-          <p:cNvPr id="25" name="Text 18"/>
-          <p:cNvSpPr txBox="1"/>
-          <p:nvPr/>
-        </p:nvSpPr>
-        <p:spPr>
-          <a:xfrm>
-            <a:off x="4754880" y="5102352"/>
-            <a:ext cx="3291840" cy="822960"/>
+            <a:endParaRPr lang="en-US" sz="1600" dirty="0"/>
+          </a:p>
+        </p:txBody>
+      </p:sp>
+      <p:sp>
+        <p:nvSpPr>
+          <p:cNvPr id="26" name="Text 19"/>
+          <p:cNvSpPr txBox="1"/>
+          <p:nvPr/>
+        </p:nvSpPr>
+        <p:spPr>
+          <a:xfrm>
+            <a:off x="4343400" y="5102352"/>
+            <a:ext cx="2926080" cy="822960"/>
           </a:xfrm>
           <a:prstGeom prst="rect">
             <a:avLst/>
@@ -17443,7 +17468,7 @@
               <a:buNone/>
             </a:pPr>
             <a:r>
-              <a:rPr lang="en-US" sz="1250" dirty="0">
+              <a:rPr lang="en-US" sz="1200" dirty="0">
                 <a:solidFill>
                   <a:srgbClr val="BDBDBD"/>
                 </a:solidFill>
@@ -17453,13 +17478,13 @@
               </a:rPr>
               <a:t>Durations built from recorded actuals; lessons learned reviewed with Valero after every job</a:t>
             </a:r>
-            <a:endParaRPr lang="en-US" sz="1250" dirty="0"/>
-          </a:p>
-        </p:txBody>
-      </p:sp>
-      <p:sp>
-        <p:nvSpPr>
-          <p:cNvPr id="26" name="Text 19"/>
+            <a:endParaRPr lang="en-US" sz="1200" dirty="0"/>
+          </a:p>
+        </p:txBody>
+      </p:sp>
+      <p:sp>
+        <p:nvSpPr>
+          <p:cNvPr id="27" name="Text 20"/>
           <p:cNvSpPr txBox="1"/>
           <p:nvPr/>
         </p:nvSpPr>
@@ -17498,7 +17523,7 @@
       </p:sp>
       <p:sp>
         <p:nvSpPr>
-          <p:cNvPr id="27" name="Text 20"/>
+          <p:cNvPr id="28" name="Text 21"/>
           <p:cNvSpPr txBox="1"/>
           <p:nvPr/>
         </p:nvSpPr>
@@ -19606,93 +19631,19 @@
           <a:chExt cx="0" cy="0"/>
         </a:xfrm>
       </p:grpSpPr>
-      <p:pic>
-        <p:nvPicPr>
-          <p:cNvPr id="2" name="Image 0" descr="C:\Users\Jwuts\obsidian-work\02-facilities\Valero\Texas-City-TX\pigging-capabilities-presentation\build/img/slot_road.jpg">    </p:cNvPr>
-          <p:cNvPicPr>
-            <a:picLocks noChangeAspect="1"/>
-          </p:cNvPicPr>
-          <p:nvPr/>
-        </p:nvPicPr>
-        <p:blipFill>
-          <a:blip r:embed="rId1"/>
-          <a:stretch>
-            <a:fillRect/>
-          </a:stretch>
-        </p:blipFill>
-        <p:spPr>
-          <a:xfrm>
-            <a:off x="0" y="0"/>
-            <a:ext cx="12191695" cy="6858000"/>
-          </a:xfrm>
-          <a:prstGeom prst="rect">
-            <a:avLst/>
-          </a:prstGeom>
-        </p:spPr>
-      </p:pic>
-      <p:pic>
-        <p:nvPicPr>
-          <p:cNvPr id="3" name="Image 1" descr="C:\Users\Jwuts\obsidian-work\02-facilities\Valero\Texas-City-TX\pigging-capabilities-presentation\build/img/fade_left.png">    </p:cNvPr>
-          <p:cNvPicPr>
-            <a:picLocks noChangeAspect="1"/>
-          </p:cNvPicPr>
-          <p:nvPr/>
-        </p:nvPicPr>
-        <p:blipFill>
-          <a:blip r:embed="rId2"/>
-          <a:stretch>
-            <a:fillRect/>
-          </a:stretch>
-        </p:blipFill>
-        <p:spPr>
-          <a:xfrm>
-            <a:off x="0" y="0"/>
-            <a:ext cx="12191695" cy="6858000"/>
-          </a:xfrm>
-          <a:prstGeom prst="rect">
-            <a:avLst/>
-          </a:prstGeom>
-        </p:spPr>
-      </p:pic>
-      <p:pic>
-        <p:nvPicPr>
-          <p:cNvPr id="4" name="Image 2" descr="C:\Users\Jwuts\obsidian-work\02-facilities\Valero\Texas-City-TX\pigging-capabilities-presentation\build/img/fade_left.png">    </p:cNvPr>
-          <p:cNvPicPr>
-            <a:picLocks noChangeAspect="1"/>
-          </p:cNvPicPr>
-          <p:nvPr/>
-        </p:nvPicPr>
-        <p:blipFill>
-          <a:blip r:embed="rId3"/>
-          <a:stretch>
-            <a:fillRect/>
-          </a:stretch>
-        </p:blipFill>
-        <p:spPr>
-          <a:xfrm>
-            <a:off x="0" y="0"/>
-            <a:ext cx="9601200" cy="6858000"/>
-          </a:xfrm>
-          <a:prstGeom prst="rect">
-            <a:avLst/>
-          </a:prstGeom>
-        </p:spPr>
-      </p:pic>
-      <p:sp>
-        <p:nvSpPr>
-          <p:cNvPr id="5" name="Shape 0"/>
+      <p:sp>
+        <p:nvSpPr>
+          <p:cNvPr id="2" name="Shape 0"/>
           <p:cNvSpPr/>
           <p:nvPr/>
         </p:nvSpPr>
         <p:spPr>
           <a:xfrm>
-            <a:off x="548640" y="411480"/>
-            <a:ext cx="2216963" cy="310896"/>
-          </a:xfrm>
-          <a:prstGeom prst="roundRect">
-            <a:avLst>
-              <a:gd name="adj" fmla="val 23529"/>
-            </a:avLst>
+            <a:off x="5918911" y="1956816"/>
+            <a:ext cx="5779008" cy="3298698"/>
+          </a:xfrm>
+          <a:prstGeom prst="rect">
+            <a:avLst/>
           </a:prstGeom>
           <a:solidFill>
             <a:srgbClr val="FCC30A"/>
@@ -19705,10 +19656,34 @@
           </a:ln>
         </p:spPr>
       </p:sp>
-      <p:sp>
-        <p:nvSpPr>
-          <p:cNvPr id="6" name="Text 1"/>
-          <p:cNvSpPr txBox="1"/>
+      <p:pic>
+        <p:nvPicPr>
+          <p:cNvPr id="3" name="Image 0" descr="C:\Users\Jwuts\obsidian-work\02-facilities\Valero\Texas-City-TX\pigging-capabilities-presentation\build/img/why_road.jpg">    </p:cNvPr>
+          <p:cNvPicPr>
+            <a:picLocks noChangeAspect="1"/>
+          </p:cNvPicPr>
+          <p:nvPr/>
+        </p:nvPicPr>
+        <p:blipFill>
+          <a:blip r:embed="rId1"/>
+          <a:stretch>
+            <a:fillRect/>
+          </a:stretch>
+        </p:blipFill>
+        <p:spPr>
+          <a:xfrm>
+            <a:off x="5973775" y="2011680"/>
+            <a:ext cx="5669280" cy="3188970"/>
+          </a:xfrm>
+          <a:prstGeom prst="rect">
+            <a:avLst/>
+          </a:prstGeom>
+        </p:spPr>
+      </p:pic>
+      <p:sp>
+        <p:nvSpPr>
+          <p:cNvPr id="4" name="Shape 1"/>
+          <p:cNvSpPr/>
           <p:nvPr/>
         </p:nvSpPr>
         <p:spPr>
@@ -19716,86 +19691,10 @@
             <a:off x="548640" y="411480"/>
             <a:ext cx="2216963" cy="310896"/>
           </a:xfrm>
-          <a:prstGeom prst="rect">
-            <a:avLst/>
-          </a:prstGeom>
-          <a:noFill/>
-          <a:ln/>
-        </p:spPr>
-        <p:txBody>
-          <a:bodyPr wrap="square" lIns="0" tIns="0" rIns="0" bIns="0" rtlCol="0" anchor="ctr"/>
-          <a:lstStyle/>
-          <a:p>
-            <a:pPr algn="ctr" indent="0" marL="0">
-              <a:buNone/>
-            </a:pPr>
-            <a:r>
-              <a:rPr lang="en-US" sz="1050" b="1" spc="150" kern="0" dirty="0">
-                <a:solidFill>
-                  <a:srgbClr val="1E1E1E"/>
-                </a:solidFill>
-                <a:latin typeface="Arial" pitchFamily="34" charset="0"/>
-                <a:ea typeface="Arial" pitchFamily="34" charset="-122"/>
-                <a:cs typeface="Arial" pitchFamily="34" charset="-120"/>
-              </a:rPr>
-              <a:t>10   WHY USA DEBUSK</a:t>
-            </a:r>
-            <a:endParaRPr lang="en-US" sz="1050" dirty="0"/>
-          </a:p>
-        </p:txBody>
-      </p:sp>
-      <p:sp>
-        <p:nvSpPr>
-          <p:cNvPr id="7" name="Text 2"/>
-          <p:cNvSpPr txBox="1"/>
-          <p:nvPr/>
-        </p:nvSpPr>
-        <p:spPr>
-          <a:xfrm>
-            <a:off x="548640" y="841248"/>
-            <a:ext cx="8229600" cy="731520"/>
-          </a:xfrm>
-          <a:prstGeom prst="rect">
-            <a:avLst/>
-          </a:prstGeom>
-          <a:noFill/>
-          <a:ln/>
-        </p:spPr>
-        <p:txBody>
-          <a:bodyPr wrap="square" lIns="0" tIns="0" rIns="0" bIns="0" rtlCol="0" anchor="t"/>
-          <a:lstStyle/>
-          <a:p>
-            <a:pPr indent="0" marL="0">
-              <a:buNone/>
-            </a:pPr>
-            <a:r>
-              <a:rPr lang="en-US" sz="3200" b="1" dirty="0">
-                <a:solidFill>
-                  <a:srgbClr val="FFFFFF"/>
-                </a:solidFill>
-                <a:latin typeface="Arial" pitchFamily="34" charset="0"/>
-                <a:ea typeface="Arial" pitchFamily="34" charset="-122"/>
-                <a:cs typeface="Arial" pitchFamily="34" charset="-120"/>
-              </a:rPr>
-              <a:t>Why USA DeBusk for Texas City</a:t>
-            </a:r>
-            <a:endParaRPr lang="en-US" sz="3200" dirty="0"/>
-          </a:p>
-        </p:txBody>
-      </p:sp>
-      <p:sp>
-        <p:nvSpPr>
-          <p:cNvPr id="8" name="Shape 3"/>
-          <p:cNvSpPr/>
-          <p:nvPr/>
-        </p:nvSpPr>
-        <p:spPr>
-          <a:xfrm>
-            <a:off x="548640" y="1920240"/>
-            <a:ext cx="502920" cy="502920"/>
-          </a:xfrm>
-          <a:prstGeom prst="ellipse">
-            <a:avLst/>
+          <a:prstGeom prst="roundRect">
+            <a:avLst>
+              <a:gd name="adj" fmla="val 23529"/>
+            </a:avLst>
           </a:prstGeom>
           <a:solidFill>
             <a:srgbClr val="FCC30A"/>
@@ -19808,56 +19707,71 @@
           </a:ln>
         </p:spPr>
       </p:sp>
-      <p:pic>
-        <p:nvPicPr>
-          <p:cNvPr id="9" name="Image 3" descr="preencoded.png">    </p:cNvPr>
-          <p:cNvPicPr>
-            <a:picLocks noChangeAspect="1"/>
-          </p:cNvPicPr>
-          <p:nvPr/>
-        </p:nvPicPr>
-        <p:blipFill>
-          <a:blip r:embed="rId4"/>
-          <a:stretch>
-            <a:fillRect/>
-          </a:stretch>
-        </p:blipFill>
-        <p:spPr>
-          <a:xfrm>
-            <a:off x="674370" y="2045970"/>
-            <a:ext cx="251460" cy="251460"/>
-          </a:xfrm>
-          <a:prstGeom prst="rect">
-            <a:avLst/>
-          </a:prstGeom>
-        </p:spPr>
-      </p:pic>
-      <p:sp>
-        <p:nvSpPr>
-          <p:cNvPr id="10" name="Text 4"/>
-          <p:cNvSpPr txBox="1"/>
-          <p:nvPr/>
-        </p:nvSpPr>
-        <p:spPr>
-          <a:xfrm>
-            <a:off x="1234440" y="1874520"/>
-            <a:ext cx="5486400" cy="320040"/>
-          </a:xfrm>
-          <a:prstGeom prst="rect">
-            <a:avLst/>
-          </a:prstGeom>
-          <a:noFill/>
-          <a:ln/>
-        </p:spPr>
-        <p:txBody>
-          <a:bodyPr wrap="square" lIns="0" tIns="0" rIns="0" bIns="0" rtlCol="0" anchor="ctr"/>
-          <a:lstStyle/>
-          <a:p>
-            <a:pPr indent="0" marL="0">
-              <a:buNone/>
-            </a:pPr>
-            <a:r>
-              <a:rPr lang="en-US" sz="1800" b="1" dirty="0">
+      <p:sp>
+        <p:nvSpPr>
+          <p:cNvPr id="5" name="Text 2"/>
+          <p:cNvSpPr txBox="1"/>
+          <p:nvPr/>
+        </p:nvSpPr>
+        <p:spPr>
+          <a:xfrm>
+            <a:off x="548640" y="411480"/>
+            <a:ext cx="2216963" cy="310896"/>
+          </a:xfrm>
+          <a:prstGeom prst="rect">
+            <a:avLst/>
+          </a:prstGeom>
+          <a:noFill/>
+          <a:ln/>
+        </p:spPr>
+        <p:txBody>
+          <a:bodyPr wrap="square" lIns="0" tIns="0" rIns="0" bIns="0" rtlCol="0" anchor="ctr"/>
+          <a:lstStyle/>
+          <a:p>
+            <a:pPr algn="ctr" indent="0" marL="0">
+              <a:buNone/>
+            </a:pPr>
+            <a:r>
+              <a:rPr lang="en-US" sz="1050" b="1" spc="150" kern="0" dirty="0">
+                <a:solidFill>
+                  <a:srgbClr val="1E1E1E"/>
+                </a:solidFill>
+                <a:latin typeface="Arial" pitchFamily="34" charset="0"/>
+                <a:ea typeface="Arial" pitchFamily="34" charset="-122"/>
+                <a:cs typeface="Arial" pitchFamily="34" charset="-120"/>
+              </a:rPr>
+              <a:t>10   WHY USA DEBUSK</a:t>
+            </a:r>
+            <a:endParaRPr lang="en-US" sz="1050" dirty="0"/>
+          </a:p>
+        </p:txBody>
+      </p:sp>
+      <p:sp>
+        <p:nvSpPr>
+          <p:cNvPr id="6" name="Text 3"/>
+          <p:cNvSpPr txBox="1"/>
+          <p:nvPr/>
+        </p:nvSpPr>
+        <p:spPr>
+          <a:xfrm>
+            <a:off x="548640" y="841248"/>
+            <a:ext cx="11064240" cy="731520"/>
+          </a:xfrm>
+          <a:prstGeom prst="rect">
+            <a:avLst/>
+          </a:prstGeom>
+          <a:noFill/>
+          <a:ln/>
+        </p:spPr>
+        <p:txBody>
+          <a:bodyPr wrap="square" lIns="0" tIns="0" rIns="0" bIns="0" rtlCol="0" anchor="t"/>
+          <a:lstStyle/>
+          <a:p>
+            <a:pPr indent="0" marL="0">
+              <a:buNone/>
+            </a:pPr>
+            <a:r>
+              <a:rPr lang="en-US" sz="3200" b="1" dirty="0">
                 <a:solidFill>
                   <a:srgbClr val="FFFFFF"/>
                 </a:solidFill>
@@ -19865,60 +19779,21 @@
                 <a:ea typeface="Arial" pitchFamily="34" charset="-122"/>
                 <a:cs typeface="Arial" pitchFamily="34" charset="-120"/>
               </a:rPr>
-              <a:t>Proven at Valero</a:t>
-            </a:r>
-            <a:endParaRPr lang="en-US" sz="1800" dirty="0"/>
-          </a:p>
-        </p:txBody>
-      </p:sp>
-      <p:sp>
-        <p:nvSpPr>
-          <p:cNvPr id="11" name="Text 5"/>
-          <p:cNvSpPr txBox="1"/>
-          <p:nvPr/>
-        </p:nvSpPr>
-        <p:spPr>
-          <a:xfrm>
-            <a:off x="1234440" y="2203704"/>
-            <a:ext cx="5486400" cy="274320"/>
-          </a:xfrm>
-          <a:prstGeom prst="rect">
-            <a:avLst/>
-          </a:prstGeom>
-          <a:noFill/>
-          <a:ln/>
-        </p:spPr>
-        <p:txBody>
-          <a:bodyPr wrap="square" lIns="0" tIns="0" rIns="0" bIns="0" rtlCol="0" anchor="ctr"/>
-          <a:lstStyle/>
-          <a:p>
-            <a:pPr indent="0" marL="0">
-              <a:buNone/>
-            </a:pPr>
-            <a:r>
-              <a:rPr lang="en-US" sz="1300" dirty="0">
-                <a:solidFill>
-                  <a:srgbClr val="BDBDBD"/>
-                </a:solidFill>
-                <a:latin typeface="Arial" pitchFamily="34" charset="0"/>
-                <a:ea typeface="Arial" pitchFamily="34" charset="-122"/>
-                <a:cs typeface="Arial" pitchFamily="34" charset="-120"/>
-              </a:rPr>
-              <a:t>14 heaters at 5 Valero refineries, your coker heater among them</a:t>
-            </a:r>
-            <a:endParaRPr lang="en-US" sz="1300" dirty="0"/>
-          </a:p>
-        </p:txBody>
-      </p:sp>
-      <p:sp>
-        <p:nvSpPr>
-          <p:cNvPr id="12" name="Shape 6"/>
+              <a:t>Why USA DeBusk for Texas City</a:t>
+            </a:r>
+            <a:endParaRPr lang="en-US" sz="3200" dirty="0"/>
+          </a:p>
+        </p:txBody>
+      </p:sp>
+      <p:sp>
+        <p:nvSpPr>
+          <p:cNvPr id="7" name="Shape 4"/>
           <p:cNvSpPr/>
           <p:nvPr/>
         </p:nvSpPr>
         <p:spPr>
           <a:xfrm>
-            <a:off x="548640" y="2761488"/>
+            <a:off x="548640" y="1920240"/>
             <a:ext cx="502920" cy="502920"/>
           </a:xfrm>
           <a:prstGeom prst="ellipse">
@@ -19937,21 +19812,21 @@
       </p:sp>
       <p:pic>
         <p:nvPicPr>
-          <p:cNvPr id="13" name="Image 4" descr="preencoded.png">    </p:cNvPr>
+          <p:cNvPr id="8" name="Image 1" descr="preencoded.png">    </p:cNvPr>
           <p:cNvPicPr>
             <a:picLocks noChangeAspect="1"/>
           </p:cNvPicPr>
           <p:nvPr/>
         </p:nvPicPr>
         <p:blipFill>
-          <a:blip r:embed="rId5"/>
+          <a:blip r:embed="rId2"/>
           <a:stretch>
             <a:fillRect/>
           </a:stretch>
         </p:blipFill>
         <p:spPr>
           <a:xfrm>
-            <a:off x="674370" y="2887218"/>
+            <a:off x="674370" y="2045970"/>
             <a:ext cx="251460" cy="251460"/>
           </a:xfrm>
           <a:prstGeom prst="rect">
@@ -19961,14 +19836,14 @@
       </p:pic>
       <p:sp>
         <p:nvSpPr>
-          <p:cNvPr id="14" name="Text 7"/>
-          <p:cNvSpPr txBox="1"/>
-          <p:nvPr/>
-        </p:nvSpPr>
-        <p:spPr>
-          <a:xfrm>
-            <a:off x="1234440" y="2715768"/>
-            <a:ext cx="5486400" cy="320040"/>
+          <p:cNvPr id="9" name="Text 5"/>
+          <p:cNvSpPr txBox="1"/>
+          <p:nvPr/>
+        </p:nvSpPr>
+        <p:spPr>
+          <a:xfrm>
+            <a:off x="1234440" y="1874520"/>
+            <a:ext cx="4480560" cy="320040"/>
           </a:xfrm>
           <a:prstGeom prst="rect">
             <a:avLst/>
@@ -19992,7 +19867,7 @@
                 <a:ea typeface="Arial" pitchFamily="34" charset="-122"/>
                 <a:cs typeface="Arial" pitchFamily="34" charset="-120"/>
               </a:rPr>
-              <a:t>Close by</a:t>
+              <a:t>Proven at Valero</a:t>
             </a:r>
             <a:endParaRPr lang="en-US" sz="1800" dirty="0"/>
           </a:p>
@@ -20000,30 +19875,30 @@
       </p:sp>
       <p:sp>
         <p:nvSpPr>
-          <p:cNvPr id="15" name="Text 8"/>
-          <p:cNvSpPr txBox="1"/>
-          <p:nvPr/>
-        </p:nvSpPr>
-        <p:spPr>
-          <a:xfrm>
-            <a:off x="1234440" y="3044952"/>
-            <a:ext cx="5486400" cy="274320"/>
-          </a:xfrm>
-          <a:prstGeom prst="rect">
-            <a:avLst/>
-          </a:prstGeom>
-          <a:noFill/>
-          <a:ln/>
-        </p:spPr>
-        <p:txBody>
-          <a:bodyPr wrap="square" lIns="0" tIns="0" rIns="0" bIns="0" rtlCol="0" anchor="ctr"/>
-          <a:lstStyle/>
-          <a:p>
-            <a:pPr indent="0" marL="0">
-              <a:buNone/>
-            </a:pPr>
-            <a:r>
-              <a:rPr lang="en-US" sz="1300" dirty="0">
+          <p:cNvPr id="10" name="Text 6"/>
+          <p:cNvSpPr txBox="1"/>
+          <p:nvPr/>
+        </p:nvSpPr>
+        <p:spPr>
+          <a:xfrm>
+            <a:off x="1234440" y="2203704"/>
+            <a:ext cx="4480560" cy="457200"/>
+          </a:xfrm>
+          <a:prstGeom prst="rect">
+            <a:avLst/>
+          </a:prstGeom>
+          <a:noFill/>
+          <a:ln/>
+        </p:spPr>
+        <p:txBody>
+          <a:bodyPr wrap="square" lIns="0" tIns="0" rIns="0" bIns="0" rtlCol="0" anchor="t"/>
+          <a:lstStyle/>
+          <a:p>
+            <a:pPr indent="0" marL="0">
+              <a:buNone/>
+            </a:pPr>
+            <a:r>
+              <a:rPr lang="en-US" sz="1200" dirty="0">
                 <a:solidFill>
                   <a:srgbClr val="BDBDBD"/>
                 </a:solidFill>
@@ -20031,21 +19906,21 @@
                 <a:ea typeface="Arial" pitchFamily="34" charset="-122"/>
                 <a:cs typeface="Arial" pitchFamily="34" charset="-120"/>
               </a:rPr>
-              <a:t>Fleet based in Deer Park, a short drive from Texas City</a:t>
-            </a:r>
-            <a:endParaRPr lang="en-US" sz="1300" dirty="0"/>
-          </a:p>
-        </p:txBody>
-      </p:sp>
-      <p:sp>
-        <p:nvSpPr>
-          <p:cNvPr id="16" name="Shape 9"/>
+              <a:t>14 heaters at 5 Valero refineries, your coker heater among them</a:t>
+            </a:r>
+            <a:endParaRPr lang="en-US" sz="1200" dirty="0"/>
+          </a:p>
+        </p:txBody>
+      </p:sp>
+      <p:sp>
+        <p:nvSpPr>
+          <p:cNvPr id="11" name="Shape 7"/>
           <p:cNvSpPr/>
           <p:nvPr/>
         </p:nvSpPr>
         <p:spPr>
           <a:xfrm>
-            <a:off x="548640" y="3602736"/>
+            <a:off x="548640" y="2761488"/>
             <a:ext cx="502920" cy="502920"/>
           </a:xfrm>
           <a:prstGeom prst="ellipse">
@@ -20064,21 +19939,21 @@
       </p:sp>
       <p:pic>
         <p:nvPicPr>
-          <p:cNvPr id="17" name="Image 5" descr="preencoded.png">    </p:cNvPr>
+          <p:cNvPr id="12" name="Image 2" descr="preencoded.png">    </p:cNvPr>
           <p:cNvPicPr>
             <a:picLocks noChangeAspect="1"/>
           </p:cNvPicPr>
           <p:nvPr/>
         </p:nvPicPr>
         <p:blipFill>
-          <a:blip r:embed="rId6"/>
+          <a:blip r:embed="rId3"/>
           <a:stretch>
             <a:fillRect/>
           </a:stretch>
         </p:blipFill>
         <p:spPr>
           <a:xfrm>
-            <a:off x="674370" y="3728466"/>
+            <a:off x="674370" y="2887218"/>
             <a:ext cx="251460" cy="251460"/>
           </a:xfrm>
           <a:prstGeom prst="rect">
@@ -20088,14 +19963,14 @@
       </p:pic>
       <p:sp>
         <p:nvSpPr>
-          <p:cNvPr id="18" name="Text 10"/>
-          <p:cNvSpPr txBox="1"/>
-          <p:nvPr/>
-        </p:nvSpPr>
-        <p:spPr>
-          <a:xfrm>
-            <a:off x="1234440" y="3557016"/>
-            <a:ext cx="5486400" cy="320040"/>
+          <p:cNvPr id="13" name="Text 8"/>
+          <p:cNvSpPr txBox="1"/>
+          <p:nvPr/>
+        </p:nvSpPr>
+        <p:spPr>
+          <a:xfrm>
+            <a:off x="1234440" y="2715768"/>
+            <a:ext cx="4480560" cy="320040"/>
           </a:xfrm>
           <a:prstGeom prst="rect">
             <a:avLst/>
@@ -20119,7 +19994,7 @@
                 <a:ea typeface="Arial" pitchFamily="34" charset="-122"/>
                 <a:cs typeface="Arial" pitchFamily="34" charset="-120"/>
               </a:rPr>
-              <a:t>Resilient execution</a:t>
+              <a:t>Close by</a:t>
             </a:r>
             <a:endParaRPr lang="en-US" sz="1800" dirty="0"/>
           </a:p>
@@ -20127,30 +20002,30 @@
       </p:sp>
       <p:sp>
         <p:nvSpPr>
-          <p:cNvPr id="19" name="Text 11"/>
-          <p:cNvSpPr txBox="1"/>
-          <p:nvPr/>
-        </p:nvSpPr>
-        <p:spPr>
-          <a:xfrm>
-            <a:off x="1234440" y="3886200"/>
-            <a:ext cx="5486400" cy="274320"/>
-          </a:xfrm>
-          <a:prstGeom prst="rect">
-            <a:avLst/>
-          </a:prstGeom>
-          <a:noFill/>
-          <a:ln/>
-        </p:spPr>
-        <p:txBody>
-          <a:bodyPr wrap="square" lIns="0" tIns="0" rIns="0" bIns="0" rtlCol="0" anchor="ctr"/>
-          <a:lstStyle/>
-          <a:p>
-            <a:pPr indent="0" marL="0">
-              <a:buNone/>
-            </a:pPr>
-            <a:r>
-              <a:rPr lang="en-US" sz="1300" dirty="0">
+          <p:cNvPr id="14" name="Text 9"/>
+          <p:cNvSpPr txBox="1"/>
+          <p:nvPr/>
+        </p:nvSpPr>
+        <p:spPr>
+          <a:xfrm>
+            <a:off x="1234440" y="3044952"/>
+            <a:ext cx="4480560" cy="457200"/>
+          </a:xfrm>
+          <a:prstGeom prst="rect">
+            <a:avLst/>
+          </a:prstGeom>
+          <a:noFill/>
+          <a:ln/>
+        </p:spPr>
+        <p:txBody>
+          <a:bodyPr wrap="square" lIns="0" tIns="0" rIns="0" bIns="0" rtlCol="0" anchor="t"/>
+          <a:lstStyle/>
+          <a:p>
+            <a:pPr indent="0" marL="0">
+              <a:buNone/>
+            </a:pPr>
+            <a:r>
+              <a:rPr lang="en-US" sz="1200" dirty="0">
                 <a:solidFill>
                   <a:srgbClr val="BDBDBD"/>
                 </a:solidFill>
@@ -20158,21 +20033,21 @@
                 <a:ea typeface="Arial" pitchFamily="34" charset="-122"/>
                 <a:cs typeface="Arial" pitchFamily="34" charset="-120"/>
               </a:rPr>
-              <a:t>Triple-pass TriMax: a spare pump on every 2-pass heater</a:t>
-            </a:r>
-            <a:endParaRPr lang="en-US" sz="1300" dirty="0"/>
-          </a:p>
-        </p:txBody>
-      </p:sp>
-      <p:sp>
-        <p:nvSpPr>
-          <p:cNvPr id="20" name="Shape 12"/>
+              <a:t>Fleet based in Deer Park, a short drive from Texas City</a:t>
+            </a:r>
+            <a:endParaRPr lang="en-US" sz="1200" dirty="0"/>
+          </a:p>
+        </p:txBody>
+      </p:sp>
+      <p:sp>
+        <p:nvSpPr>
+          <p:cNvPr id="15" name="Shape 10"/>
           <p:cNvSpPr/>
           <p:nvPr/>
         </p:nvSpPr>
         <p:spPr>
           <a:xfrm>
-            <a:off x="548640" y="4443984"/>
+            <a:off x="548640" y="3602736"/>
             <a:ext cx="502920" cy="502920"/>
           </a:xfrm>
           <a:prstGeom prst="ellipse">
@@ -20191,21 +20066,21 @@
       </p:sp>
       <p:pic>
         <p:nvPicPr>
-          <p:cNvPr id="21" name="Image 6" descr="preencoded.png">    </p:cNvPr>
+          <p:cNvPr id="16" name="Image 3" descr="preencoded.png">    </p:cNvPr>
           <p:cNvPicPr>
             <a:picLocks noChangeAspect="1"/>
           </p:cNvPicPr>
           <p:nvPr/>
         </p:nvPicPr>
         <p:blipFill>
-          <a:blip r:embed="rId7"/>
+          <a:blip r:embed="rId4"/>
           <a:stretch>
             <a:fillRect/>
           </a:stretch>
         </p:blipFill>
         <p:spPr>
           <a:xfrm>
-            <a:off x="674370" y="4569714"/>
+            <a:off x="674370" y="3728466"/>
             <a:ext cx="251460" cy="251460"/>
           </a:xfrm>
           <a:prstGeom prst="rect">
@@ -20215,14 +20090,14 @@
       </p:pic>
       <p:sp>
         <p:nvSpPr>
-          <p:cNvPr id="22" name="Text 13"/>
-          <p:cNvSpPr txBox="1"/>
-          <p:nvPr/>
-        </p:nvSpPr>
-        <p:spPr>
-          <a:xfrm>
-            <a:off x="1234440" y="4398264"/>
-            <a:ext cx="5486400" cy="320040"/>
+          <p:cNvPr id="17" name="Text 11"/>
+          <p:cNvSpPr txBox="1"/>
+          <p:nvPr/>
+        </p:nvSpPr>
+        <p:spPr>
+          <a:xfrm>
+            <a:off x="1234440" y="3557016"/>
+            <a:ext cx="4480560" cy="320040"/>
           </a:xfrm>
           <a:prstGeom prst="rect">
             <a:avLst/>
@@ -20246,7 +20121,7 @@
                 <a:ea typeface="Arial" pitchFamily="34" charset="-122"/>
                 <a:cs typeface="Arial" pitchFamily="34" charset="-120"/>
               </a:rPr>
-              <a:t>Verified clean</a:t>
+              <a:t>Resilient execution</a:t>
             </a:r>
             <a:endParaRPr lang="en-US" sz="1800" dirty="0"/>
           </a:p>
@@ -20254,30 +20129,30 @@
       </p:sp>
       <p:sp>
         <p:nvSpPr>
-          <p:cNvPr id="23" name="Text 14"/>
-          <p:cNvSpPr txBox="1"/>
-          <p:nvPr/>
-        </p:nvSpPr>
-        <p:spPr>
-          <a:xfrm>
-            <a:off x="1234440" y="4727448"/>
-            <a:ext cx="5486400" cy="274320"/>
-          </a:xfrm>
-          <a:prstGeom prst="rect">
-            <a:avLst/>
-          </a:prstGeom>
-          <a:noFill/>
-          <a:ln/>
-        </p:spPr>
-        <p:txBody>
-          <a:bodyPr wrap="square" lIns="0" tIns="0" rIns="0" bIns="0" rtlCol="0" anchor="ctr"/>
-          <a:lstStyle/>
-          <a:p>
-            <a:pPr indent="0" marL="0">
-              <a:buNone/>
-            </a:pPr>
-            <a:r>
-              <a:rPr lang="en-US" sz="1300" dirty="0">
+          <p:cNvPr id="18" name="Text 12"/>
+          <p:cNvSpPr txBox="1"/>
+          <p:nvPr/>
+        </p:nvSpPr>
+        <p:spPr>
+          <a:xfrm>
+            <a:off x="1234440" y="3886200"/>
+            <a:ext cx="4480560" cy="457200"/>
+          </a:xfrm>
+          <a:prstGeom prst="rect">
+            <a:avLst/>
+          </a:prstGeom>
+          <a:noFill/>
+          <a:ln/>
+        </p:spPr>
+        <p:txBody>
+          <a:bodyPr wrap="square" lIns="0" tIns="0" rIns="0" bIns="0" rtlCol="0" anchor="t"/>
+          <a:lstStyle/>
+          <a:p>
+            <a:pPr indent="0" marL="0">
+              <a:buNone/>
+            </a:pPr>
+            <a:r>
+              <a:rPr lang="en-US" sz="1200" dirty="0">
                 <a:solidFill>
                   <a:srgbClr val="BDBDBD"/>
                 </a:solidFill>
@@ -20285,21 +20160,21 @@
                 <a:ea typeface="Arial" pitchFamily="34" charset="-122"/>
                 <a:cs typeface="Arial" pitchFamily="34" charset="-120"/>
               </a:rPr>
-              <a:t>4-point verification and joint sign-off on every pass</a:t>
-            </a:r>
-            <a:endParaRPr lang="en-US" sz="1300" dirty="0"/>
-          </a:p>
-        </p:txBody>
-      </p:sp>
-      <p:sp>
-        <p:nvSpPr>
-          <p:cNvPr id="24" name="Shape 15"/>
+              <a:t>Triple-pass TriMax: a spare pump on every 2-pass heater</a:t>
+            </a:r>
+            <a:endParaRPr lang="en-US" sz="1200" dirty="0"/>
+          </a:p>
+        </p:txBody>
+      </p:sp>
+      <p:sp>
+        <p:nvSpPr>
+          <p:cNvPr id="19" name="Shape 13"/>
           <p:cNvSpPr/>
           <p:nvPr/>
         </p:nvSpPr>
         <p:spPr>
           <a:xfrm>
-            <a:off x="548640" y="5285232"/>
+            <a:off x="548640" y="4443984"/>
             <a:ext cx="502920" cy="502920"/>
           </a:xfrm>
           <a:prstGeom prst="ellipse">
@@ -20318,20 +20193,147 @@
       </p:sp>
       <p:pic>
         <p:nvPicPr>
-          <p:cNvPr id="25" name="Image 7" descr="preencoded.png">    </p:cNvPr>
+          <p:cNvPr id="20" name="Image 4" descr="preencoded.png">    </p:cNvPr>
           <p:cNvPicPr>
             <a:picLocks noChangeAspect="1"/>
           </p:cNvPicPr>
           <p:nvPr/>
         </p:nvPicPr>
         <p:blipFill>
-          <a:blip r:embed="rId8"/>
+          <a:blip r:embed="rId5"/>
           <a:stretch>
             <a:fillRect/>
           </a:stretch>
         </p:blipFill>
         <p:spPr>
           <a:xfrm>
+            <a:off x="674370" y="4569714"/>
+            <a:ext cx="251460" cy="251460"/>
+          </a:xfrm>
+          <a:prstGeom prst="rect">
+            <a:avLst/>
+          </a:prstGeom>
+        </p:spPr>
+      </p:pic>
+      <p:sp>
+        <p:nvSpPr>
+          <p:cNvPr id="21" name="Text 14"/>
+          <p:cNvSpPr txBox="1"/>
+          <p:nvPr/>
+        </p:nvSpPr>
+        <p:spPr>
+          <a:xfrm>
+            <a:off x="1234440" y="4398264"/>
+            <a:ext cx="4480560" cy="320040"/>
+          </a:xfrm>
+          <a:prstGeom prst="rect">
+            <a:avLst/>
+          </a:prstGeom>
+          <a:noFill/>
+          <a:ln/>
+        </p:spPr>
+        <p:txBody>
+          <a:bodyPr wrap="square" lIns="0" tIns="0" rIns="0" bIns="0" rtlCol="0" anchor="ctr"/>
+          <a:lstStyle/>
+          <a:p>
+            <a:pPr indent="0" marL="0">
+              <a:buNone/>
+            </a:pPr>
+            <a:r>
+              <a:rPr lang="en-US" sz="1800" b="1" dirty="0">
+                <a:solidFill>
+                  <a:srgbClr val="FFFFFF"/>
+                </a:solidFill>
+                <a:latin typeface="Arial" pitchFamily="34" charset="0"/>
+                <a:ea typeface="Arial" pitchFamily="34" charset="-122"/>
+                <a:cs typeface="Arial" pitchFamily="34" charset="-120"/>
+              </a:rPr>
+              <a:t>Verified clean</a:t>
+            </a:r>
+            <a:endParaRPr lang="en-US" sz="1800" dirty="0"/>
+          </a:p>
+        </p:txBody>
+      </p:sp>
+      <p:sp>
+        <p:nvSpPr>
+          <p:cNvPr id="22" name="Text 15"/>
+          <p:cNvSpPr txBox="1"/>
+          <p:nvPr/>
+        </p:nvSpPr>
+        <p:spPr>
+          <a:xfrm>
+            <a:off x="1234440" y="4727448"/>
+            <a:ext cx="4480560" cy="457200"/>
+          </a:xfrm>
+          <a:prstGeom prst="rect">
+            <a:avLst/>
+          </a:prstGeom>
+          <a:noFill/>
+          <a:ln/>
+        </p:spPr>
+        <p:txBody>
+          <a:bodyPr wrap="square" lIns="0" tIns="0" rIns="0" bIns="0" rtlCol="0" anchor="t"/>
+          <a:lstStyle/>
+          <a:p>
+            <a:pPr indent="0" marL="0">
+              <a:buNone/>
+            </a:pPr>
+            <a:r>
+              <a:rPr lang="en-US" sz="1200" dirty="0">
+                <a:solidFill>
+                  <a:srgbClr val="BDBDBD"/>
+                </a:solidFill>
+                <a:latin typeface="Arial" pitchFamily="34" charset="0"/>
+                <a:ea typeface="Arial" pitchFamily="34" charset="-122"/>
+                <a:cs typeface="Arial" pitchFamily="34" charset="-120"/>
+              </a:rPr>
+              <a:t>4-point verification and joint sign-off on every pass</a:t>
+            </a:r>
+            <a:endParaRPr lang="en-US" sz="1200" dirty="0"/>
+          </a:p>
+        </p:txBody>
+      </p:sp>
+      <p:sp>
+        <p:nvSpPr>
+          <p:cNvPr id="23" name="Shape 16"/>
+          <p:cNvSpPr/>
+          <p:nvPr/>
+        </p:nvSpPr>
+        <p:spPr>
+          <a:xfrm>
+            <a:off x="548640" y="5285232"/>
+            <a:ext cx="502920" cy="502920"/>
+          </a:xfrm>
+          <a:prstGeom prst="ellipse">
+            <a:avLst/>
+          </a:prstGeom>
+          <a:solidFill>
+            <a:srgbClr val="FCC30A"/>
+          </a:solidFill>
+          <a:ln w="12700">
+            <a:solidFill>
+              <a:srgbClr val="FCC30A"/>
+            </a:solidFill>
+            <a:prstDash val="solid"/>
+          </a:ln>
+        </p:spPr>
+      </p:sp>
+      <p:pic>
+        <p:nvPicPr>
+          <p:cNvPr id="24" name="Image 5" descr="preencoded.png">    </p:cNvPr>
+          <p:cNvPicPr>
+            <a:picLocks noChangeAspect="1"/>
+          </p:cNvPicPr>
+          <p:nvPr/>
+        </p:nvPicPr>
+        <p:blipFill>
+          <a:blip r:embed="rId6"/>
+          <a:stretch>
+            <a:fillRect/>
+          </a:stretch>
+        </p:blipFill>
+        <p:spPr>
+          <a:xfrm>
             <a:off x="674370" y="5410962"/>
             <a:ext cx="251460" cy="251460"/>
           </a:xfrm>
@@ -20342,14 +20344,14 @@
       </p:pic>
       <p:sp>
         <p:nvSpPr>
-          <p:cNvPr id="26" name="Text 16"/>
+          <p:cNvPr id="25" name="Text 17"/>
           <p:cNvSpPr txBox="1"/>
           <p:nvPr/>
         </p:nvSpPr>
         <p:spPr>
           <a:xfrm>
             <a:off x="1234440" y="5239512"/>
-            <a:ext cx="5486400" cy="320040"/>
+            <a:ext cx="4480560" cy="320040"/>
           </a:xfrm>
           <a:prstGeom prst="rect">
             <a:avLst/>
@@ -20381,30 +20383,30 @@
       </p:sp>
       <p:sp>
         <p:nvSpPr>
-          <p:cNvPr id="27" name="Text 17"/>
+          <p:cNvPr id="26" name="Text 18"/>
           <p:cNvSpPr txBox="1"/>
           <p:nvPr/>
         </p:nvSpPr>
         <p:spPr>
           <a:xfrm>
             <a:off x="1234440" y="5568696"/>
-            <a:ext cx="5486400" cy="274320"/>
-          </a:xfrm>
-          <a:prstGeom prst="rect">
-            <a:avLst/>
-          </a:prstGeom>
-          <a:noFill/>
-          <a:ln/>
-        </p:spPr>
-        <p:txBody>
-          <a:bodyPr wrap="square" lIns="0" tIns="0" rIns="0" bIns="0" rtlCol="0" anchor="ctr"/>
-          <a:lstStyle/>
-          <a:p>
-            <a:pPr indent="0" marL="0">
-              <a:buNone/>
-            </a:pPr>
-            <a:r>
-              <a:rPr lang="en-US" sz="1300" dirty="0">
+            <a:ext cx="4480560" cy="457200"/>
+          </a:xfrm>
+          <a:prstGeom prst="rect">
+            <a:avLst/>
+          </a:prstGeom>
+          <a:noFill/>
+          <a:ln/>
+        </p:spPr>
+        <p:txBody>
+          <a:bodyPr wrap="square" lIns="0" tIns="0" rIns="0" bIns="0" rtlCol="0" anchor="t"/>
+          <a:lstStyle/>
+          <a:p>
+            <a:pPr indent="0" marL="0">
+              <a:buNone/>
+            </a:pPr>
+            <a:r>
+              <a:rPr lang="en-US" sz="1200" dirty="0">
                 <a:solidFill>
                   <a:srgbClr val="BDBDBD"/>
                 </a:solidFill>
@@ -20414,13 +20416,13 @@
               </a:rPr>
               <a:t>EMR 0.48, ISNetworld A, zero fatalities in 3 years</a:t>
             </a:r>
-            <a:endParaRPr lang="en-US" sz="1300" dirty="0"/>
-          </a:p>
-        </p:txBody>
-      </p:sp>
-      <p:sp>
-        <p:nvSpPr>
-          <p:cNvPr id="28" name="Text 18"/>
+            <a:endParaRPr lang="en-US" sz="1200" dirty="0"/>
+          </a:p>
+        </p:txBody>
+      </p:sp>
+      <p:sp>
+        <p:nvSpPr>
+          <p:cNvPr id="27" name="Text 19"/>
           <p:cNvSpPr txBox="1"/>
           <p:nvPr/>
         </p:nvSpPr>
@@ -20459,7 +20461,7 @@
       </p:sp>
       <p:sp>
         <p:nvSpPr>
-          <p:cNvPr id="29" name="Text 19"/>
+          <p:cNvPr id="28" name="Text 20"/>
           <p:cNvSpPr txBox="1"/>
           <p:nvPr/>
         </p:nvSpPr>
@@ -20728,7 +20730,7 @@
       </p:grpSpPr>
       <p:pic>
         <p:nvPicPr>
-          <p:cNvPr id="2" name="Image 0" descr="C:\Users\Jwuts\obsidian-work\02-facilities\Valero\Texas-City-TX\pigging-capabilities-presentation\build/img/onsite_40.jpg">    </p:cNvPr>
+          <p:cNvPr id="2" name="Image 0" descr="C:\Users\Jwuts\obsidian-work\02-facilities\Valero\Texas-City-TX\pigging-capabilities-presentation\build/img/services_heater.jpg">    </p:cNvPr>
           <p:cNvPicPr>
             <a:picLocks noChangeAspect="1"/>
           </p:cNvPicPr>
@@ -21921,9 +21923,34 @@
           <a:chExt cx="0" cy="0"/>
         </a:xfrm>
       </p:grpSpPr>
+      <p:sp>
+        <p:nvSpPr>
+          <p:cNvPr id="2" name="Shape 0"/>
+          <p:cNvSpPr/>
+          <p:nvPr/>
+        </p:nvSpPr>
+        <p:spPr>
+          <a:xfrm>
+            <a:off x="7958023" y="2194560"/>
+            <a:ext cx="3730752" cy="1858528"/>
+          </a:xfrm>
+          <a:prstGeom prst="rect">
+            <a:avLst/>
+          </a:prstGeom>
+          <a:solidFill>
+            <a:srgbClr val="FFFFFF"/>
+          </a:solidFill>
+          <a:ln w="12700">
+            <a:solidFill>
+              <a:srgbClr val="DDDDDD"/>
+            </a:solidFill>
+            <a:prstDash val="solid"/>
+          </a:ln>
+        </p:spPr>
+      </p:sp>
       <p:pic>
         <p:nvPicPr>
-          <p:cNvPr id="2" name="Image 0" descr="C:\Users\Jwuts\obsidian-work\02-facilities\Valero\Texas-City-TX\pigging-capabilities-presentation\build/img/slot_method_t6.jpg">    </p:cNvPr>
+          <p:cNvPr id="3" name="Image 0" descr="C:\Users\Jwuts\obsidian-work\02-facilities\Valero\Texas-City-TX\pigging-capabilities-presentation\build/img/pigs_lineup.jpg">    </p:cNvPr>
           <p:cNvPicPr>
             <a:picLocks noChangeAspect="1"/>
           </p:cNvPicPr>
@@ -21937,8 +21964,8 @@
         </p:blipFill>
         <p:spPr>
           <a:xfrm>
-            <a:off x="8531352" y="0"/>
-            <a:ext cx="3657600" cy="6858000"/>
+            <a:off x="8003743" y="2240280"/>
+            <a:ext cx="3639312" cy="1767088"/>
           </a:xfrm>
           <a:prstGeom prst="rect">
             <a:avLst/>
@@ -21947,7 +21974,46 @@
       </p:pic>
       <p:sp>
         <p:nvSpPr>
-          <p:cNvPr id="3" name="Shape 0"/>
+          <p:cNvPr id="4" name="Text 1"/>
+          <p:cNvSpPr txBox="1"/>
+          <p:nvPr/>
+        </p:nvSpPr>
+        <p:spPr>
+          <a:xfrm>
+            <a:off x="8003743" y="4144528"/>
+            <a:ext cx="3639312" cy="457200"/>
+          </a:xfrm>
+          <a:prstGeom prst="rect">
+            <a:avLst/>
+          </a:prstGeom>
+          <a:noFill/>
+          <a:ln/>
+        </p:spPr>
+        <p:txBody>
+          <a:bodyPr wrap="square" lIns="0" tIns="0" rIns="0" bIns="0" rtlCol="0" anchor="t"/>
+          <a:lstStyle/>
+          <a:p>
+            <a:pPr algn="ctr" indent="0" marL="0">
+              <a:buNone/>
+            </a:pPr>
+            <a:r>
+              <a:rPr lang="en-US" sz="1050" i="1" dirty="0">
+                <a:solidFill>
+                  <a:srgbClr val="5E5E5E"/>
+                </a:solidFill>
+                <a:latin typeface="Arial" pitchFamily="34" charset="0"/>
+                <a:ea typeface="Arial" pitchFamily="34" charset="-122"/>
+                <a:cs typeface="Arial" pitchFamily="34" charset="-120"/>
+              </a:rPr>
+              <a:t>Scraper pigs after runs: wear marks show where coke remains</a:t>
+            </a:r>
+            <a:endParaRPr lang="en-US" sz="1050" dirty="0"/>
+          </a:p>
+        </p:txBody>
+      </p:sp>
+      <p:sp>
+        <p:nvSpPr>
+          <p:cNvPr id="5" name="Shape 2"/>
           <p:cNvSpPr/>
           <p:nvPr/>
         </p:nvSpPr>
@@ -21974,7 +22040,7 @@
       </p:sp>
       <p:sp>
         <p:nvSpPr>
-          <p:cNvPr id="4" name="Text 1"/>
+          <p:cNvPr id="6" name="Text 3"/>
           <p:cNvSpPr txBox="1"/>
           <p:nvPr/>
         </p:nvSpPr>
@@ -22013,7 +22079,7 @@
       </p:sp>
       <p:sp>
         <p:nvSpPr>
-          <p:cNvPr id="5" name="Text 2"/>
+          <p:cNvPr id="7" name="Text 4"/>
           <p:cNvSpPr txBox="1"/>
           <p:nvPr/>
         </p:nvSpPr>
@@ -22052,7 +22118,7 @@
       </p:sp>
       <p:sp>
         <p:nvSpPr>
-          <p:cNvPr id="6" name="Text 3"/>
+          <p:cNvPr id="8" name="Text 5"/>
           <p:cNvSpPr txBox="1"/>
           <p:nvPr/>
         </p:nvSpPr>
@@ -22091,7 +22157,7 @@
       </p:sp>
       <p:sp>
         <p:nvSpPr>
-          <p:cNvPr id="7" name="Shape 4"/>
+          <p:cNvPr id="9" name="Shape 6"/>
           <p:cNvSpPr/>
           <p:nvPr/>
         </p:nvSpPr>
@@ -22114,7 +22180,7 @@
       </p:sp>
       <p:sp>
         <p:nvSpPr>
-          <p:cNvPr id="8" name="Shape 5"/>
+          <p:cNvPr id="10" name="Shape 7"/>
           <p:cNvSpPr/>
           <p:nvPr/>
         </p:nvSpPr>
@@ -22139,7 +22205,7 @@
       </p:sp>
       <p:sp>
         <p:nvSpPr>
-          <p:cNvPr id="9" name="Text 6"/>
+          <p:cNvPr id="11" name="Text 8"/>
           <p:cNvSpPr txBox="1"/>
           <p:nvPr/>
         </p:nvSpPr>
@@ -22178,14 +22244,14 @@
       </p:sp>
       <p:sp>
         <p:nvSpPr>
-          <p:cNvPr id="10" name="Text 7"/>
+          <p:cNvPr id="12" name="Text 9"/>
           <p:cNvSpPr txBox="1"/>
           <p:nvPr/>
         </p:nvSpPr>
         <p:spPr>
           <a:xfrm>
             <a:off x="1280160" y="2084832"/>
-            <a:ext cx="7040880" cy="274320"/>
+            <a:ext cx="6400800" cy="274320"/>
           </a:xfrm>
           <a:prstGeom prst="rect">
             <a:avLst/>
@@ -22217,14 +22283,14 @@
       </p:sp>
       <p:sp>
         <p:nvSpPr>
-          <p:cNvPr id="11" name="Text 8"/>
+          <p:cNvPr id="13" name="Text 10"/>
           <p:cNvSpPr txBox="1"/>
           <p:nvPr/>
         </p:nvSpPr>
         <p:spPr>
           <a:xfrm>
             <a:off x="1280160" y="2359152"/>
-            <a:ext cx="7040880" cy="274320"/>
+            <a:ext cx="6400800" cy="274320"/>
           </a:xfrm>
           <a:prstGeom prst="rect">
             <a:avLst/>
@@ -22256,7 +22322,7 @@
       </p:sp>
       <p:sp>
         <p:nvSpPr>
-          <p:cNvPr id="12" name="Shape 9"/>
+          <p:cNvPr id="14" name="Shape 11"/>
           <p:cNvSpPr/>
           <p:nvPr/>
         </p:nvSpPr>
@@ -22281,7 +22347,7 @@
       </p:sp>
       <p:sp>
         <p:nvSpPr>
-          <p:cNvPr id="13" name="Text 10"/>
+          <p:cNvPr id="15" name="Text 12"/>
           <p:cNvSpPr txBox="1"/>
           <p:nvPr/>
         </p:nvSpPr>
@@ -22320,14 +22386,14 @@
       </p:sp>
       <p:sp>
         <p:nvSpPr>
-          <p:cNvPr id="14" name="Text 11"/>
+          <p:cNvPr id="16" name="Text 13"/>
           <p:cNvSpPr txBox="1"/>
           <p:nvPr/>
         </p:nvSpPr>
         <p:spPr>
           <a:xfrm>
             <a:off x="1280160" y="2752344"/>
-            <a:ext cx="7040880" cy="274320"/>
+            <a:ext cx="6400800" cy="274320"/>
           </a:xfrm>
           <a:prstGeom prst="rect">
             <a:avLst/>
@@ -22359,14 +22425,14 @@
       </p:sp>
       <p:sp>
         <p:nvSpPr>
-          <p:cNvPr id="15" name="Text 12"/>
+          <p:cNvPr id="17" name="Text 14"/>
           <p:cNvSpPr txBox="1"/>
           <p:nvPr/>
         </p:nvSpPr>
         <p:spPr>
           <a:xfrm>
             <a:off x="1280160" y="3026664"/>
-            <a:ext cx="7040880" cy="274320"/>
+            <a:ext cx="6400800" cy="274320"/>
           </a:xfrm>
           <a:prstGeom prst="rect">
             <a:avLst/>
@@ -22398,7 +22464,7 @@
       </p:sp>
       <p:sp>
         <p:nvSpPr>
-          <p:cNvPr id="16" name="Shape 13"/>
+          <p:cNvPr id="18" name="Shape 15"/>
           <p:cNvSpPr/>
           <p:nvPr/>
         </p:nvSpPr>
@@ -22423,7 +22489,7 @@
       </p:sp>
       <p:sp>
         <p:nvSpPr>
-          <p:cNvPr id="17" name="Text 14"/>
+          <p:cNvPr id="19" name="Text 16"/>
           <p:cNvSpPr txBox="1"/>
           <p:nvPr/>
         </p:nvSpPr>
@@ -22462,14 +22528,14 @@
       </p:sp>
       <p:sp>
         <p:nvSpPr>
-          <p:cNvPr id="18" name="Text 15"/>
+          <p:cNvPr id="20" name="Text 17"/>
           <p:cNvSpPr txBox="1"/>
           <p:nvPr/>
         </p:nvSpPr>
         <p:spPr>
           <a:xfrm>
             <a:off x="1280160" y="3419856"/>
-            <a:ext cx="7040880" cy="274320"/>
+            <a:ext cx="6400800" cy="274320"/>
           </a:xfrm>
           <a:prstGeom prst="rect">
             <a:avLst/>
@@ -22501,14 +22567,14 @@
       </p:sp>
       <p:sp>
         <p:nvSpPr>
-          <p:cNvPr id="19" name="Text 16"/>
+          <p:cNvPr id="21" name="Text 18"/>
           <p:cNvSpPr txBox="1"/>
           <p:nvPr/>
         </p:nvSpPr>
         <p:spPr>
           <a:xfrm>
             <a:off x="1280160" y="3694176"/>
-            <a:ext cx="7040880" cy="274320"/>
+            <a:ext cx="6400800" cy="274320"/>
           </a:xfrm>
           <a:prstGeom prst="rect">
             <a:avLst/>
@@ -22540,7 +22606,7 @@
       </p:sp>
       <p:sp>
         <p:nvSpPr>
-          <p:cNvPr id="20" name="Shape 17"/>
+          <p:cNvPr id="22" name="Shape 19"/>
           <p:cNvSpPr/>
           <p:nvPr/>
         </p:nvSpPr>
@@ -22565,7 +22631,7 @@
       </p:sp>
       <p:sp>
         <p:nvSpPr>
-          <p:cNvPr id="21" name="Text 18"/>
+          <p:cNvPr id="23" name="Text 20"/>
           <p:cNvSpPr txBox="1"/>
           <p:nvPr/>
         </p:nvSpPr>
@@ -22604,14 +22670,14 @@
       </p:sp>
       <p:sp>
         <p:nvSpPr>
-          <p:cNvPr id="22" name="Text 19"/>
+          <p:cNvPr id="24" name="Text 21"/>
           <p:cNvSpPr txBox="1"/>
           <p:nvPr/>
         </p:nvSpPr>
         <p:spPr>
           <a:xfrm>
             <a:off x="1280160" y="4087368"/>
-            <a:ext cx="7040880" cy="274320"/>
+            <a:ext cx="6400800" cy="274320"/>
           </a:xfrm>
           <a:prstGeom prst="rect">
             <a:avLst/>
@@ -22643,14 +22709,14 @@
       </p:sp>
       <p:sp>
         <p:nvSpPr>
-          <p:cNvPr id="23" name="Text 20"/>
+          <p:cNvPr id="25" name="Text 22"/>
           <p:cNvSpPr txBox="1"/>
           <p:nvPr/>
         </p:nvSpPr>
         <p:spPr>
           <a:xfrm>
             <a:off x="1280160" y="4361688"/>
-            <a:ext cx="7040880" cy="274320"/>
+            <a:ext cx="6400800" cy="274320"/>
           </a:xfrm>
           <a:prstGeom prst="rect">
             <a:avLst/>
@@ -22682,7 +22748,7 @@
       </p:sp>
       <p:sp>
         <p:nvSpPr>
-          <p:cNvPr id="24" name="Shape 21"/>
+          <p:cNvPr id="26" name="Shape 23"/>
           <p:cNvSpPr/>
           <p:nvPr/>
         </p:nvSpPr>
@@ -22707,7 +22773,7 @@
       </p:sp>
       <p:sp>
         <p:nvSpPr>
-          <p:cNvPr id="25" name="Text 22"/>
+          <p:cNvPr id="27" name="Text 24"/>
           <p:cNvSpPr txBox="1"/>
           <p:nvPr/>
         </p:nvSpPr>
@@ -22746,14 +22812,14 @@
       </p:sp>
       <p:sp>
         <p:nvSpPr>
-          <p:cNvPr id="26" name="Text 23"/>
+          <p:cNvPr id="28" name="Text 25"/>
           <p:cNvSpPr txBox="1"/>
           <p:nvPr/>
         </p:nvSpPr>
         <p:spPr>
           <a:xfrm>
             <a:off x="1280160" y="4754880"/>
-            <a:ext cx="7040880" cy="274320"/>
+            <a:ext cx="6400800" cy="274320"/>
           </a:xfrm>
           <a:prstGeom prst="rect">
             <a:avLst/>
@@ -22785,14 +22851,14 @@
       </p:sp>
       <p:sp>
         <p:nvSpPr>
-          <p:cNvPr id="27" name="Text 24"/>
+          <p:cNvPr id="29" name="Text 26"/>
           <p:cNvSpPr txBox="1"/>
           <p:nvPr/>
         </p:nvSpPr>
         <p:spPr>
           <a:xfrm>
             <a:off x="1280160" y="5029200"/>
-            <a:ext cx="7040880" cy="274320"/>
+            <a:ext cx="6400800" cy="274320"/>
           </a:xfrm>
           <a:prstGeom prst="rect">
             <a:avLst/>
@@ -22824,7 +22890,7 @@
       </p:sp>
       <p:sp>
         <p:nvSpPr>
-          <p:cNvPr id="28" name="Shape 25"/>
+          <p:cNvPr id="30" name="Shape 27"/>
           <p:cNvSpPr/>
           <p:nvPr/>
         </p:nvSpPr>
@@ -22849,7 +22915,7 @@
       </p:sp>
       <p:sp>
         <p:nvSpPr>
-          <p:cNvPr id="29" name="Text 26"/>
+          <p:cNvPr id="31" name="Text 28"/>
           <p:cNvSpPr txBox="1"/>
           <p:nvPr/>
         </p:nvSpPr>
@@ -22888,14 +22954,14 @@
       </p:sp>
       <p:sp>
         <p:nvSpPr>
-          <p:cNvPr id="30" name="Text 27"/>
+          <p:cNvPr id="32" name="Text 29"/>
           <p:cNvSpPr txBox="1"/>
           <p:nvPr/>
         </p:nvSpPr>
         <p:spPr>
           <a:xfrm>
             <a:off x="1280160" y="5422392"/>
-            <a:ext cx="7040880" cy="274320"/>
+            <a:ext cx="6400800" cy="274320"/>
           </a:xfrm>
           <a:prstGeom prst="rect">
             <a:avLst/>
@@ -22927,14 +22993,14 @@
       </p:sp>
       <p:sp>
         <p:nvSpPr>
-          <p:cNvPr id="31" name="Text 28"/>
+          <p:cNvPr id="33" name="Text 30"/>
           <p:cNvSpPr txBox="1"/>
           <p:nvPr/>
         </p:nvSpPr>
         <p:spPr>
           <a:xfrm>
             <a:off x="1280160" y="5696712"/>
-            <a:ext cx="7040880" cy="274320"/>
+            <a:ext cx="6400800" cy="274320"/>
           </a:xfrm>
           <a:prstGeom prst="rect">
             <a:avLst/>
@@ -22966,7 +23032,7 @@
       </p:sp>
       <p:sp>
         <p:nvSpPr>
-          <p:cNvPr id="32" name="Text 29"/>
+          <p:cNvPr id="34" name="Text 31"/>
           <p:cNvSpPr txBox="1"/>
           <p:nvPr/>
         </p:nvSpPr>
@@ -23005,7 +23071,7 @@
       </p:sp>
       <p:sp>
         <p:nvSpPr>
-          <p:cNvPr id="33" name="Text 30"/>
+          <p:cNvPr id="35" name="Text 32"/>
           <p:cNvSpPr txBox="1"/>
           <p:nvPr/>
         </p:nvSpPr>
@@ -28548,7 +28614,7 @@
       </p:grpSpPr>
       <p:pic>
         <p:nvPicPr>
-          <p:cNvPr id="2" name="Image 0" descr="C:\Users\Jwuts\obsidian-work\02-facilities\Valero\Texas-City-TX\pigging-capabilities-presentation\build/img/slot_ready.jpg">    </p:cNvPr>
+          <p:cNvPr id="2" name="Image 0" descr="C:\Users\Jwuts\obsidian-work\02-facilities\Valero\Texas-City-TX\pigging-capabilities-presentation\build/img/card_ready.jpg">    </p:cNvPr>
           <p:cNvPicPr>
             <a:picLocks noChangeAspect="1"/>
           </p:cNvPicPr>
@@ -28562,8 +28628,8 @@
         </p:blipFill>
         <p:spPr>
           <a:xfrm>
-            <a:off x="0" y="0"/>
-            <a:ext cx="4206240" cy="6858000"/>
+            <a:off x="7592263" y="1783080"/>
+            <a:ext cx="4050792" cy="1910917"/>
           </a:xfrm>
           <a:prstGeom prst="rect">
             <a:avLst/>
@@ -28578,7 +28644,7 @@
         </p:nvSpPr>
         <p:spPr>
           <a:xfrm>
-            <a:off x="4663440" y="411480"/>
+            <a:off x="548640" y="411480"/>
             <a:ext cx="2913583" cy="310896"/>
           </a:xfrm>
           <a:prstGeom prst="roundRect">
@@ -28605,7 +28671,7 @@
         </p:nvSpPr>
         <p:spPr>
           <a:xfrm>
-            <a:off x="4663440" y="411480"/>
+            <a:off x="548640" y="411480"/>
             <a:ext cx="2913583" cy="310896"/>
           </a:xfrm>
           <a:prstGeom prst="rect">
@@ -28644,8 +28710,8 @@
         </p:nvSpPr>
         <p:spPr>
           <a:xfrm>
-            <a:off x="4663440" y="841248"/>
-            <a:ext cx="6949440" cy="731520"/>
+            <a:off x="548640" y="841248"/>
+            <a:ext cx="11064240" cy="731520"/>
           </a:xfrm>
           <a:prstGeom prst="rect">
             <a:avLst/>
@@ -28661,7 +28727,7 @@
               <a:buNone/>
             </a:pPr>
             <a:r>
-              <a:rPr lang="en-US" sz="3000" b="1" dirty="0">
+              <a:rPr lang="en-US" sz="3200" b="1" dirty="0">
                 <a:solidFill>
                   <a:srgbClr val="222222"/>
                 </a:solidFill>
@@ -28671,7 +28737,7 @@
               </a:rPr>
               <a:t>Crew &amp; equipment, every job</a:t>
             </a:r>
-            <a:endParaRPr lang="en-US" sz="3000" dirty="0"/>
+            <a:endParaRPr lang="en-US" sz="3200" dirty="0"/>
           </a:p>
         </p:txBody>
       </p:sp>
@@ -28683,7 +28749,7 @@
         </p:nvSpPr>
         <p:spPr>
           <a:xfrm>
-            <a:off x="5212080" y="1828800"/>
+            <a:off x="1097280" y="1828800"/>
             <a:ext cx="2743200" cy="365760"/>
           </a:xfrm>
           <a:prstGeom prst="rect">
@@ -28722,7 +28788,7 @@
         </p:nvSpPr>
         <p:spPr>
           <a:xfrm>
-            <a:off x="4663440" y="2423160"/>
+            <a:off x="548640" y="2423160"/>
             <a:ext cx="502920" cy="502920"/>
           </a:xfrm>
           <a:prstGeom prst="rect">
@@ -28761,7 +28827,7 @@
         </p:nvSpPr>
         <p:spPr>
           <a:xfrm>
-            <a:off x="5212080" y="2423160"/>
+            <a:off x="1097280" y="2423160"/>
             <a:ext cx="2743200" cy="502920"/>
           </a:xfrm>
           <a:prstGeom prst="rect">
@@ -28800,7 +28866,7 @@
         </p:nvSpPr>
         <p:spPr>
           <a:xfrm>
-            <a:off x="4663440" y="3081528"/>
+            <a:off x="548640" y="3081528"/>
             <a:ext cx="502920" cy="502920"/>
           </a:xfrm>
           <a:prstGeom prst="rect">
@@ -28839,7 +28905,7 @@
         </p:nvSpPr>
         <p:spPr>
           <a:xfrm>
-            <a:off x="5212080" y="3081528"/>
+            <a:off x="1097280" y="3081528"/>
             <a:ext cx="2743200" cy="502920"/>
           </a:xfrm>
           <a:prstGeom prst="rect">
@@ -28878,7 +28944,7 @@
         </p:nvSpPr>
         <p:spPr>
           <a:xfrm>
-            <a:off x="4663440" y="3739896"/>
+            <a:off x="548640" y="3739896"/>
             <a:ext cx="502920" cy="502920"/>
           </a:xfrm>
           <a:prstGeom prst="rect">
@@ -28917,7 +28983,7 @@
         </p:nvSpPr>
         <p:spPr>
           <a:xfrm>
-            <a:off x="5212080" y="3739896"/>
+            <a:off x="1097280" y="3739896"/>
             <a:ext cx="2743200" cy="502920"/>
           </a:xfrm>
           <a:prstGeom prst="rect">
@@ -28956,7 +29022,7 @@
         </p:nvSpPr>
         <p:spPr>
           <a:xfrm>
-            <a:off x="8732520" y="1828800"/>
+            <a:off x="4617720" y="1828800"/>
             <a:ext cx="2743200" cy="365760"/>
           </a:xfrm>
           <a:prstGeom prst="rect">
@@ -28995,7 +29061,7 @@
         </p:nvSpPr>
         <p:spPr>
           <a:xfrm>
-            <a:off x="8183880" y="2423160"/>
+            <a:off x="4069080" y="2423160"/>
             <a:ext cx="502920" cy="502920"/>
           </a:xfrm>
           <a:prstGeom prst="rect">
@@ -29034,7 +29100,7 @@
         </p:nvSpPr>
         <p:spPr>
           <a:xfrm>
-            <a:off x="8732520" y="2423160"/>
+            <a:off x="4617720" y="2423160"/>
             <a:ext cx="2743200" cy="502920"/>
           </a:xfrm>
           <a:prstGeom prst="rect">
@@ -29073,7 +29139,7 @@
         </p:nvSpPr>
         <p:spPr>
           <a:xfrm>
-            <a:off x="8183880" y="3081528"/>
+            <a:off x="4069080" y="3081528"/>
             <a:ext cx="502920" cy="502920"/>
           </a:xfrm>
           <a:prstGeom prst="rect">
@@ -29112,7 +29178,7 @@
         </p:nvSpPr>
         <p:spPr>
           <a:xfrm>
-            <a:off x="8732520" y="3081528"/>
+            <a:off x="4617720" y="3081528"/>
             <a:ext cx="2743200" cy="502920"/>
           </a:xfrm>
           <a:prstGeom prst="rect">
@@ -29151,7 +29217,7 @@
         </p:nvSpPr>
         <p:spPr>
           <a:xfrm>
-            <a:off x="8183880" y="3739896"/>
+            <a:off x="4069080" y="3739896"/>
             <a:ext cx="502920" cy="502920"/>
           </a:xfrm>
           <a:prstGeom prst="rect">
@@ -29190,7 +29256,7 @@
         </p:nvSpPr>
         <p:spPr>
           <a:xfrm>
-            <a:off x="8732520" y="3739896"/>
+            <a:off x="4617720" y="3739896"/>
             <a:ext cx="2743200" cy="502920"/>
           </a:xfrm>
           <a:prstGeom prst="rect">
@@ -29229,7 +29295,7 @@
         </p:nvSpPr>
         <p:spPr>
           <a:xfrm>
-            <a:off x="4663440" y="1783080"/>
+            <a:off x="548640" y="1783080"/>
             <a:ext cx="438912" cy="438912"/>
           </a:xfrm>
           <a:prstGeom prst="ellipse">
@@ -29262,7 +29328,7 @@
         </p:blipFill>
         <p:spPr>
           <a:xfrm>
-            <a:off x="4773168" y="1892808"/>
+            <a:off x="658368" y="1892808"/>
             <a:ext cx="219456" cy="219456"/>
           </a:xfrm>
           <a:prstGeom prst="rect">
@@ -29278,7 +29344,7 @@
         </p:nvSpPr>
         <p:spPr>
           <a:xfrm>
-            <a:off x="8183880" y="1783080"/>
+            <a:off x="4069080" y="1783080"/>
             <a:ext cx="438912" cy="438912"/>
           </a:xfrm>
           <a:prstGeom prst="ellipse">
@@ -29311,7 +29377,7 @@
         </p:blipFill>
         <p:spPr>
           <a:xfrm>
-            <a:off x="8293608" y="1892808"/>
+            <a:off x="4178808" y="1892808"/>
             <a:ext cx="219456" cy="219456"/>
           </a:xfrm>
           <a:prstGeom prst="rect">
@@ -29327,8 +29393,8 @@
         </p:nvSpPr>
         <p:spPr>
           <a:xfrm>
-            <a:off x="4663440" y="4617720"/>
-            <a:ext cx="2148840" cy="1417320"/>
+            <a:off x="548640" y="4617720"/>
+            <a:ext cx="3593592" cy="1417320"/>
           </a:xfrm>
           <a:prstGeom prst="rect">
             <a:avLst/>
@@ -29352,8 +29418,8 @@
         </p:nvSpPr>
         <p:spPr>
           <a:xfrm>
-            <a:off x="4846320" y="4754880"/>
-            <a:ext cx="1828800" cy="640080"/>
+            <a:off x="777240" y="4754880"/>
+            <a:ext cx="3108960" cy="640080"/>
           </a:xfrm>
           <a:prstGeom prst="rect">
             <a:avLst/>
@@ -29391,8 +29457,8 @@
         </p:nvSpPr>
         <p:spPr>
           <a:xfrm>
-            <a:off x="4846320" y="5394960"/>
-            <a:ext cx="1828800" cy="548640"/>
+            <a:off x="777240" y="5394960"/>
+            <a:ext cx="3108960" cy="548640"/>
           </a:xfrm>
           <a:prstGeom prst="rect">
             <a:avLst/>
@@ -29408,7 +29474,7 @@
               <a:buNone/>
             </a:pPr>
             <a:r>
-              <a:rPr lang="en-US" sz="1150" dirty="0">
+              <a:rPr lang="en-US" sz="1200" dirty="0">
                 <a:solidFill>
                   <a:srgbClr val="FFFFFF"/>
                 </a:solidFill>
@@ -29418,7 +29484,7 @@
               </a:rPr>
               <a:t>crew turnover, last 12 months</a:t>
             </a:r>
-            <a:endParaRPr lang="en-US" sz="1150" dirty="0"/>
+            <a:endParaRPr lang="en-US" sz="1200" dirty="0"/>
           </a:p>
         </p:txBody>
       </p:sp>
@@ -29430,8 +29496,8 @@
         </p:nvSpPr>
         <p:spPr>
           <a:xfrm>
-            <a:off x="6995160" y="4617720"/>
-            <a:ext cx="2148840" cy="1417320"/>
+            <a:off x="4297680" y="4617720"/>
+            <a:ext cx="3593592" cy="1417320"/>
           </a:xfrm>
           <a:prstGeom prst="rect">
             <a:avLst/>
@@ -29455,8 +29521,8 @@
         </p:nvSpPr>
         <p:spPr>
           <a:xfrm>
-            <a:off x="7178040" y="4754880"/>
-            <a:ext cx="1828800" cy="640080"/>
+            <a:off x="4526280" y="4754880"/>
+            <a:ext cx="3108960" cy="640080"/>
           </a:xfrm>
           <a:prstGeom prst="rect">
             <a:avLst/>
@@ -29494,8 +29560,8 @@
         </p:nvSpPr>
         <p:spPr>
           <a:xfrm>
-            <a:off x="7178040" y="5394960"/>
-            <a:ext cx="1828800" cy="548640"/>
+            <a:off x="4526280" y="5394960"/>
+            <a:ext cx="3108960" cy="548640"/>
           </a:xfrm>
           <a:prstGeom prst="rect">
             <a:avLst/>
@@ -29511,7 +29577,7 @@
               <a:buNone/>
             </a:pPr>
             <a:r>
-              <a:rPr lang="en-US" sz="1150" dirty="0">
+              <a:rPr lang="en-US" sz="1200" dirty="0">
                 <a:solidFill>
                   <a:srgbClr val="FFFFFF"/>
                 </a:solidFill>
@@ -29521,7 +29587,7 @@
               </a:rPr>
               <a:t>two 12-hour shifts</a:t>
             </a:r>
-            <a:endParaRPr lang="en-US" sz="1150" dirty="0"/>
+            <a:endParaRPr lang="en-US" sz="1200" dirty="0"/>
           </a:p>
         </p:txBody>
       </p:sp>
@@ -29533,8 +29599,8 @@
         </p:nvSpPr>
         <p:spPr>
           <a:xfrm>
-            <a:off x="9326880" y="4617720"/>
-            <a:ext cx="2148840" cy="1417320"/>
+            <a:off x="8046720" y="4617720"/>
+            <a:ext cx="3593592" cy="1417320"/>
           </a:xfrm>
           <a:prstGeom prst="rect">
             <a:avLst/>
@@ -29558,8 +29624,8 @@
         </p:nvSpPr>
         <p:spPr>
           <a:xfrm>
-            <a:off x="9509760" y="4754880"/>
-            <a:ext cx="1828800" cy="640080"/>
+            <a:off x="8275320" y="4754880"/>
+            <a:ext cx="3108960" cy="640080"/>
           </a:xfrm>
           <a:prstGeom prst="rect">
             <a:avLst/>
@@ -29597,8 +29663,8 @@
         </p:nvSpPr>
         <p:spPr>
           <a:xfrm>
-            <a:off x="9509760" y="5394960"/>
-            <a:ext cx="1828800" cy="548640"/>
+            <a:off x="8275320" y="5394960"/>
+            <a:ext cx="3108960" cy="548640"/>
           </a:xfrm>
           <a:prstGeom prst="rect">
             <a:avLst/>
@@ -29614,7 +29680,7 @@
               <a:buNone/>
             </a:pPr>
             <a:r>
-              <a:rPr lang="en-US" sz="1150" dirty="0">
+              <a:rPr lang="en-US" sz="1200" dirty="0">
                 <a:solidFill>
                   <a:srgbClr val="FFFFFF"/>
                 </a:solidFill>
@@ -29624,7 +29690,7 @@
               </a:rPr>
               <a:t>training verified before mobilization</a:t>
             </a:r>
-            <a:endParaRPr lang="en-US" sz="1150" dirty="0"/>
+            <a:endParaRPr lang="en-US" sz="1200" dirty="0"/>
           </a:p>
         </p:txBody>
       </p:sp>
@@ -29636,7 +29702,7 @@
         </p:nvSpPr>
         <p:spPr>
           <a:xfrm>
-            <a:off x="4663440" y="6419088"/>
+            <a:off x="548640" y="6419088"/>
             <a:ext cx="7315200" cy="228600"/>
           </a:xfrm>
           <a:prstGeom prst="rect">

</xml_diff>

<commit_message>
[Lane 1] valero-txc: wording pass for customer polish
Shop-floor phrasing replaced ("the tech scrubs", "Black", "no subs",
"nobody in line with lids"); internal jargon ("triple mode") spelled out;
the absolute "sign-offs from all of our clients" line, which slide 22's
smart-pig finding contradicted, replaced; on-slide superlatives softened;
pump-curve form number dropped.

Co-Authored-By: Claude Opus 5.5 <noreply@anthropic.com>
</commit_message>
<xml_diff>
--- a/02-facilities/Valero/Texas-City-TX/pigging-capabilities-presentation/Valero_TXC_Pigging_Capabilities.pptx
+++ b/02-facilities/Valero/Texas-City-TX/pigging-capabilities-presentation/Valero_TXC_Pigging_Capabilities.pptx
@@ -5301,7 +5301,7 @@
                 <a:ea typeface="Arial" pitchFamily="34" charset="-122"/>
                 <a:cs typeface="Arial" pitchFamily="34" charset="-120"/>
               </a:rPr>
-              <a:t>Field Tech</a:t>
+              <a:t>Field Technician</a:t>
             </a:r>
             <a:endParaRPr lang="en-US" sz="900" dirty="0"/>
           </a:p>
@@ -7781,7 +7781,7 @@
                 <a:ea typeface="Arial" pitchFamily="34" charset="-122"/>
                 <a:cs typeface="Arial" pitchFamily="34" charset="-120"/>
               </a:rPr>
-              <a:t>Manufacturer curve: Waterous Company, form F-2692</a:t>
+              <a:t>Manufacturer pump curve: Waterous Company</a:t>
             </a:r>
             <a:endParaRPr lang="en-US" sz="950" dirty="0"/>
           </a:p>
@@ -11343,7 +11343,7 @@
                 <a:ea typeface="Arial" pitchFamily="34" charset="-122"/>
                 <a:cs typeface="Arial" pitchFamily="34" charset="-120"/>
               </a:rPr>
-              <a:t>Coke shows as a pressure spike; the tech stops and scrubs that exact spot</a:t>
+              <a:t>Coke shows as a pressure spike; the operator works that location until it clears</a:t>
             </a:r>
             <a:endParaRPr lang="en-US" sz="1150" dirty="0"/>
           </a:p>
@@ -11495,7 +11495,7 @@
                 <a:ea typeface="Arial" pitchFamily="34" charset="-122"/>
                 <a:cs typeface="Arial" pitchFamily="34" charset="-120"/>
               </a:rPr>
-              <a:t>"Black" in the return stream fades to nothing as the pass cleans</a:t>
+              <a:t>Coke fines in the return stream taper off to nothing as the pass cleans</a:t>
             </a:r>
             <a:endParaRPr lang="en-US" sz="1150" dirty="0"/>
           </a:p>
@@ -11905,7 +11905,7 @@
                 <a:ea typeface="Arial" pitchFamily="34" charset="-122"/>
                 <a:cs typeface="Arial" pitchFamily="34" charset="-120"/>
               </a:rPr>
-              <a:t>Field-proven process: successful sign-offs from all of our clients and reliable first-attempt smart pig data.</a:t>
+              <a:t>A pass is called clean only when all four indicators agree.</a:t>
             </a:r>
             <a:endParaRPr lang="en-US" sz="1200" dirty="0"/>
           </a:p>
@@ -15078,7 +15078,7 @@
                 <a:ea typeface="Arial" pitchFamily="34" charset="-122"/>
                 <a:cs typeface="Arial" pitchFamily="34" charset="-120"/>
               </a:rPr>
-              <a:t>Bleed to zero at every pig change; nobody in line with lids or hoses</a:t>
+              <a:t>Bleed to zero at every pig change; no one in line with closures or hoses</a:t>
             </a:r>
             <a:endParaRPr lang="en-US" sz="1150" dirty="0"/>
           </a:p>
@@ -17020,7 +17020,7 @@
                 <a:ea typeface="Arial" pitchFamily="34" charset="-122"/>
                 <a:cs typeface="Arial" pitchFamily="34" charset="-120"/>
               </a:rPr>
-              <a:t>Pigging, decoking and hydroblasting with our own equipment and crews: one contractor, no subs</a:t>
+              <a:t>Pigging, decoking and hydroblasting with our own equipment and crews: one contractor, no subcontractors</a:t>
             </a:r>
             <a:endParaRPr lang="en-US" sz="1200" dirty="0"/>
           </a:p>
@@ -17133,7 +17133,7 @@
                 <a:ea typeface="Arial" pitchFamily="34" charset="-122"/>
                 <a:cs typeface="Arial" pitchFamily="34" charset="-120"/>
               </a:rPr>
-              <a:t>Largest standardized fleet</a:t>
+              <a:t>Standardized fleet</a:t>
             </a:r>
             <a:endParaRPr lang="en-US" sz="1600" dirty="0"/>
           </a:p>
@@ -17172,7 +17172,7 @@
                 <a:ea typeface="Arial" pitchFamily="34" charset="-122"/>
                 <a:cs typeface="Arial" pitchFamily="34" charset="-120"/>
               </a:rPr>
-              <a:t>6 identical TriMax units, 18 engines, with a spare pump on board even on a 2-pass heater</a:t>
+              <a:t>6 identical triple-pass TriMax units, 18 engines, with a spare pump on board even on a 2-pass heater</a:t>
             </a:r>
             <a:endParaRPr lang="en-US" sz="1200" dirty="0"/>
           </a:p>
@@ -17285,7 +17285,7 @@
                 <a:ea typeface="Arial" pitchFamily="34" charset="-122"/>
                 <a:cs typeface="Arial" pitchFamily="34" charset="-120"/>
               </a:rPr>
-              <a:t>Widest pig selection</a:t>
+              <a:t>Engineered pig selection</a:t>
             </a:r>
             <a:endParaRPr lang="en-US" sz="1600" dirty="0"/>
           </a:p>
@@ -17324,7 +17324,7 @@
                 <a:ea typeface="Arial" pitchFamily="34" charset="-122"/>
                 <a:cs typeface="Arial" pitchFamily="34" charset="-120"/>
               </a:rPr>
-              <a:t>Engineered decoking pigs matched to each coil and each coke condition</a:t>
+              <a:t>Decoking pigs matched to each coil and each coke condition</a:t>
             </a:r>
             <a:endParaRPr lang="en-US" sz="1200" dirty="0"/>
           </a:p>
@@ -18969,7 +18969,7 @@
                 <a:ea typeface="Arial" pitchFamily="34" charset="-122"/>
                 <a:cs typeface="Arial" pitchFamily="34" charset="-120"/>
               </a:rPr>
-              <a:t>Both 8-pass vacuum heaters pigged in triple mode, with filtration and smart pig inspection of every pass.</a:t>
+              <a:t>Both 8-pass vacuum heaters pigged three passes at a time, with filtration and smart pig inspection of every pass.</a:t>
             </a:r>
             <a:endParaRPr lang="en-US" sz="1300" dirty="0"/>
           </a:p>
@@ -19047,7 +19047,7 @@
                 <a:ea typeface="Arial" pitchFamily="34" charset="-122"/>
                 <a:cs typeface="Arial" pitchFamily="34" charset="-120"/>
               </a:rPr>
-              <a:t>Every pass signed clean and cleared by smart pig before rig-out. A mid-job TriMax swap rigged in within 2 hours, with no break in pigging.</a:t>
+              <a:t>Every pass signed clean and cleared by smart pig before rig-out. A replacement TriMax was rigged in mid-job within 2 hours, with no break in pigging.</a:t>
             </a:r>
             <a:endParaRPr lang="en-US" sz="1300" dirty="0"/>
           </a:p>
@@ -19994,7 +19994,7 @@
                 <a:ea typeface="Arial" pitchFamily="34" charset="-122"/>
                 <a:cs typeface="Arial" pitchFamily="34" charset="-120"/>
               </a:rPr>
-              <a:t>Close by</a:t>
+              <a:t>Local</a:t>
             </a:r>
             <a:endParaRPr lang="en-US" sz="1800" dirty="0"/>
           </a:p>
@@ -25411,7 +25411,7 @@
                 <a:ea typeface="Arial" pitchFamily="34" charset="-122"/>
                 <a:cs typeface="Arial" pitchFamily="34" charset="-120"/>
               </a:rPr>
-              <a:t>The most diverse selection of engineered decoking pigs in the world</a:t>
+              <a:t>Body, durometer and studding chosen for the coil, the coke and the metallurgy</a:t>
             </a:r>
             <a:endParaRPr lang="en-US" sz="1500" dirty="0"/>
           </a:p>
@@ -27315,7 +27315,7 @@
                 <a:ea typeface="Arial" pitchFamily="34" charset="-122"/>
                 <a:cs typeface="Arial" pitchFamily="34" charset="-120"/>
               </a:rPr>
-              <a:t>Coker, crude or vacuum service sets the pig set staged on day one</a:t>
+              <a:t>Coker, crude or vacuum service decides which pigs are staged on day one</a:t>
             </a:r>
             <a:endParaRPr lang="en-US" sz="1200" dirty="0"/>
           </a:p>
@@ -29443,7 +29443,7 @@
                 <a:ea typeface="Arial" pitchFamily="34" charset="-122"/>
                 <a:cs typeface="Arial" pitchFamily="34" charset="-120"/>
               </a:rPr>
-              <a:t>~5%</a:t>
+              <a:t>5%</a:t>
             </a:r>
             <a:endParaRPr lang="en-US" sz="3000" dirty="0"/>
           </a:p>
@@ -29482,7 +29482,7 @@
                 <a:ea typeface="Arial" pitchFamily="34" charset="-122"/>
                 <a:cs typeface="Arial" pitchFamily="34" charset="-120"/>
               </a:rPr>
-              <a:t>crew turnover, last 12 months</a:t>
+              <a:t>approximate crew turnover, last 12 months</a:t>
             </a:r>
             <a:endParaRPr lang="en-US" sz="1200" dirty="0"/>
           </a:p>

</xml_diff>